<commit_message>
June 14 integration: 8 new governance papers into HTML, Synthesis MD, DOCX, PPTX, and dashboard
</commit_message>
<xml_diff>
--- a/EvaPaper/AI_Agent_Governance_Three_Layer_Stack_and_Papers.pptx
+++ b/EvaPaper/AI_Agent_Governance_Three_Layer_Stack_and_Papers.pptx
@@ -31,6 +31,8 @@
     <p:sldId id="279" r:id="rId30"/>
     <p:sldId id="280" r:id="rId31"/>
     <p:sldId id="281" r:id="rId32"/>
+    <p:sldId id="282" r:id="rId33"/>
+    <p:sldId id="283" r:id="rId34"/>
   </p:sldIdLst>
   <p:sldSz cx="12191695" cy="6858000" type="screen4x3"/>
   <p:notesSz cx="6858000" cy="9144000"/>
@@ -3497,8 +3499,8 @@
         </p:nvSpPr>
         <p:spPr>
           <a:xfrm>
-            <a:off x="548640" y="384048"/>
-            <a:ext cx="10607040" cy="548640"/>
+            <a:off x="731520" y="2011680"/>
+            <a:ext cx="9601200" cy="914400"/>
           </a:xfrm>
           <a:prstGeom prst="rect">
             <a:avLst/>
@@ -3512,7 +3514,7 @@
           <a:lstStyle/>
           <a:p>
             <a:pPr algn="l">
-              <a:defRPr sz="2200" b="1">
+              <a:defRPr sz="3000" b="1">
                 <a:solidFill>
                   <a:srgbClr val="F5F7FA"/>
                 </a:solidFill>
@@ -3520,32 +3522,66 @@
               </a:defRPr>
             </a:pPr>
             <a:r>
-              <a:t>2. ST-WebAgentBench</a:t>
-            </a:r>
-          </a:p>
-        </p:txBody>
-      </p:sp>
-      <p:sp>
-        <p:nvSpPr>
-          <p:cNvPr id="5" name="Rounded Rectangle 4"/>
+              <a:t>Papers &amp; Products</a:t>
+            </a:r>
+          </a:p>
+        </p:txBody>
+      </p:sp>
+      <p:sp>
+        <p:nvSpPr>
+          <p:cNvPr id="5" name="TextBox 4"/>
+          <p:cNvSpPr txBox="1"/>
+          <p:nvPr/>
+        </p:nvSpPr>
+        <p:spPr>
+          <a:xfrm>
+            <a:off x="749808" y="3063240"/>
+            <a:ext cx="7772400" cy="548640"/>
+          </a:xfrm>
+          <a:prstGeom prst="rect">
+            <a:avLst/>
+          </a:prstGeom>
+          <a:noFill/>
+        </p:spPr>
+        <p:txBody>
+          <a:bodyPr wrap="square">
+            <a:spAutoFit/>
+          </a:bodyPr>
+          <a:lstStyle/>
+          <a:p>
+            <a:pPr algn="l">
+              <a:defRPr sz="1300" b="0">
+                <a:solidFill>
+                  <a:srgbClr val="C3CDDC"/>
+                </a:solidFill>
+                <a:latin typeface="Aptos"/>
+              </a:defRPr>
+            </a:pPr>
+            <a:r>
+              <a:t>Curated from the current markdown report</a:t>
+            </a:r>
+          </a:p>
+        </p:txBody>
+      </p:sp>
+      <p:sp>
+        <p:nvSpPr>
+          <p:cNvPr id="6" name="Hexagon 5"/>
           <p:cNvSpPr/>
           <p:nvPr/>
         </p:nvSpPr>
         <p:spPr>
           <a:xfrm>
-            <a:off x="502920" y="1143000"/>
-            <a:ext cx="11155680" cy="5303520"/>
-          </a:xfrm>
-          <a:prstGeom prst="roundRect">
+            <a:off x="9509760" y="1645920"/>
+            <a:ext cx="1645920" cy="1645920"/>
+          </a:xfrm>
+          <a:prstGeom prst="hexagon">
             <a:avLst/>
           </a:prstGeom>
           <a:solidFill>
-            <a:srgbClr val="18243A"/>
+            <a:srgbClr val="3ECFB9"/>
           </a:solidFill>
           <a:ln>
-            <a:solidFill>
-              <a:srgbClr val="18243A"/>
-            </a:solidFill>
+            <a:noFill/>
           </a:ln>
         </p:spPr>
         <p:style>
@@ -3572,109 +3608,6 @@
       </p:sp>
       <p:sp>
         <p:nvSpPr>
-          <p:cNvPr id="6" name="TextBox 5"/>
-          <p:cNvSpPr txBox="1"/>
-          <p:nvPr/>
-        </p:nvSpPr>
-        <p:spPr>
-          <a:xfrm>
-            <a:off x="777240" y="1463040"/>
-            <a:ext cx="10424160" cy="4572000"/>
-          </a:xfrm>
-          <a:prstGeom prst="rect">
-            <a:avLst/>
-          </a:prstGeom>
-          <a:noFill/>
-        </p:spPr>
-        <p:txBody>
-          <a:bodyPr wrap="square">
-            <a:spAutoFit/>
-          </a:bodyPr>
-          <a:lstStyle/>
-          <a:p>
-            <a:pPr>
-              <a:spcAft>
-                <a:spcPts val="1000"/>
-              </a:spcAft>
-              <a:defRPr sz="1600">
-                <a:solidFill>
-                  <a:srgbClr val="C3CDDC"/>
-                </a:solidFill>
-                <a:latin typeface="Aptos"/>
-              </a:defRPr>
-            </a:pPr>
-            <a:r>
-              <a:t>arXiv ID: 2410.06703</a:t>
-            </a:r>
-          </a:p>
-          <a:p>
-            <a:pPr>
-              <a:spcAft>
-                <a:spcPts val="1000"/>
-              </a:spcAft>
-              <a:defRPr sz="1600">
-                <a:solidFill>
-                  <a:srgbClr val="C3CDDC"/>
-                </a:solidFill>
-                <a:latin typeface="Aptos"/>
-              </a:defRPr>
-            </a:pPr>
-            <a:r>
-              <a:t>URL: https://arxiv.org/abs/2410.06703</a:t>
-            </a:r>
-          </a:p>
-          <a:p>
-            <a:pPr>
-              <a:spcAft>
-                <a:spcPts val="1000"/>
-              </a:spcAft>
-              <a:defRPr sz="1600">
-                <a:solidFill>
-                  <a:srgbClr val="C3CDDC"/>
-                </a:solidFill>
-                <a:latin typeface="Aptos"/>
-              </a:defRPr>
-            </a:pPr>
-            <a:r>
-              <a:t>PDF: https://arxiv.org/pdf/2410.06703</a:t>
-            </a:r>
-          </a:p>
-          <a:p>
-            <a:pPr>
-              <a:spcAft>
-                <a:spcPts val="1000"/>
-              </a:spcAft>
-              <a:defRPr sz="1600">
-                <a:solidFill>
-                  <a:srgbClr val="C3CDDC"/>
-                </a:solidFill>
-                <a:latin typeface="Aptos"/>
-              </a:defRPr>
-            </a:pPr>
-            <a:r>
-              <a:t>Authors: Research team focusing on web agent safety</a:t>
-            </a:r>
-          </a:p>
-          <a:p>
-            <a:pPr>
-              <a:spcAft>
-                <a:spcPts val="1000"/>
-              </a:spcAft>
-              <a:defRPr sz="1600">
-                <a:solidFill>
-                  <a:srgbClr val="C3CDDC"/>
-                </a:solidFill>
-                <a:latin typeface="Aptos"/>
-              </a:defRPr>
-            </a:pPr>
-            <a:r>
-              <a:t>Date: October 2024</a:t>
-            </a:r>
-          </a:p>
-        </p:txBody>
-      </p:sp>
-      <p:sp>
-        <p:nvSpPr>
           <p:cNvPr id="7" name="TextBox 6"/>
           <p:cNvSpPr txBox="1"/>
           <p:nvPr/>
@@ -3703,7 +3636,7 @@
               </a:defRPr>
             </a:pPr>
             <a:r>
-              <a:t>EvaPaper</a:t>
+              <a:t>Section</a:t>
             </a:r>
           </a:p>
         </p:txBody>
@@ -3843,7 +3776,7 @@
               </a:defRPr>
             </a:pPr>
             <a:r>
-              <a:t>3. Layered Governance Architecture (LGA)</a:t>
+              <a:t>1. BeSafe-Bench (BSB)</a:t>
             </a:r>
           </a:p>
         </p:txBody>
@@ -3927,7 +3860,7 @@
               </a:defRPr>
             </a:pPr>
             <a:r>
-              <a:t>arXiv ID: 2603.07191</a:t>
+              <a:t>arXiv ID: 2603.25747</a:t>
             </a:r>
           </a:p>
           <a:p>
@@ -3943,7 +3876,7 @@
               </a:defRPr>
             </a:pPr>
             <a:r>
-              <a:t>URL: https://arxiv.org/abs/2603.07191</a:t>
+              <a:t>URL: https://arxiv.org/abs/2603.25747</a:t>
             </a:r>
           </a:p>
           <a:p>
@@ -3959,7 +3892,7 @@
               </a:defRPr>
             </a:pPr>
             <a:r>
-              <a:t>PDF: https://arxiv.org/pdf/2603.07191</a:t>
+              <a:t>PDF: https://arxiv.org/pdf/2603.25747</a:t>
             </a:r>
           </a:p>
           <a:p>
@@ -3975,7 +3908,7 @@
               </a:defRPr>
             </a:pPr>
             <a:r>
-              <a:t>Authors: Security research team</a:t>
+              <a:t>Authors: Xuetao Wei et al.</a:t>
             </a:r>
           </a:p>
           <a:p>
@@ -3991,7 +3924,7 @@
               </a:defRPr>
             </a:pPr>
             <a:r>
-              <a:t>Date: March 2026</a:t>
+              <a:t>Date: January 2026</a:t>
             </a:r>
           </a:p>
         </p:txBody>
@@ -4166,7 +4099,7 @@
               </a:defRPr>
             </a:pPr>
             <a:r>
-              <a:t>4. Skilldex</a:t>
+              <a:t>2. ST-WebAgentBench</a:t>
             </a:r>
           </a:p>
         </p:txBody>
@@ -4250,7 +4183,7 @@
               </a:defRPr>
             </a:pPr>
             <a:r>
-              <a:t>arXiv ID: 2604.16911</a:t>
+              <a:t>arXiv ID: 2410.06703</a:t>
             </a:r>
           </a:p>
           <a:p>
@@ -4266,7 +4199,7 @@
               </a:defRPr>
             </a:pPr>
             <a:r>
-              <a:t>URL: https://arxiv.org/abs/2604.16911</a:t>
+              <a:t>URL: https://arxiv.org/abs/2410.06703</a:t>
             </a:r>
           </a:p>
           <a:p>
@@ -4282,7 +4215,7 @@
               </a:defRPr>
             </a:pPr>
             <a:r>
-              <a:t>PDF: https://arxiv.org/pdf/2604.16911</a:t>
+              <a:t>PDF: https://arxiv.org/pdf/2410.06703</a:t>
             </a:r>
           </a:p>
           <a:p>
@@ -4298,7 +4231,7 @@
               </a:defRPr>
             </a:pPr>
             <a:r>
-              <a:t>Authors: Skill package research team</a:t>
+              <a:t>Authors: Research team focusing on web agent safety</a:t>
             </a:r>
           </a:p>
           <a:p>
@@ -4314,7 +4247,7 @@
               </a:defRPr>
             </a:pPr>
             <a:r>
-              <a:t>Date: April 2026</a:t>
+              <a:t>Date: October 2024</a:t>
             </a:r>
           </a:p>
         </p:txBody>
@@ -4430,7 +4363,7 @@
             <a:avLst/>
           </a:prstGeom>
           <a:solidFill>
-            <a:srgbClr val="A66EFF"/>
+            <a:srgbClr val="3ECFB9"/>
           </a:solidFill>
           <a:ln>
             <a:noFill/>
@@ -4466,8 +4399,8 @@
         </p:nvSpPr>
         <p:spPr>
           <a:xfrm>
-            <a:off x="731520" y="2011680"/>
-            <a:ext cx="9601200" cy="914400"/>
+            <a:off x="548640" y="384048"/>
+            <a:ext cx="10607040" cy="548640"/>
           </a:xfrm>
           <a:prstGeom prst="rect">
             <a:avLst/>
@@ -4481,7 +4414,7 @@
           <a:lstStyle/>
           <a:p>
             <a:pPr algn="l">
-              <a:defRPr sz="3000" b="1">
+              <a:defRPr sz="2200" b="1">
                 <a:solidFill>
                   <a:srgbClr val="F5F7FA"/>
                 </a:solidFill>
@@ -4489,66 +4422,32 @@
               </a:defRPr>
             </a:pPr>
             <a:r>
-              <a:t>The Three-Layer Stack in Detail</a:t>
-            </a:r>
-          </a:p>
-        </p:txBody>
-      </p:sp>
-      <p:sp>
-        <p:nvSpPr>
-          <p:cNvPr id="5" name="TextBox 4"/>
-          <p:cNvSpPr txBox="1"/>
-          <p:nvPr/>
-        </p:nvSpPr>
-        <p:spPr>
-          <a:xfrm>
-            <a:off x="749808" y="3063240"/>
-            <a:ext cx="7772400" cy="548640"/>
-          </a:xfrm>
-          <a:prstGeom prst="rect">
-            <a:avLst/>
-          </a:prstGeom>
-          <a:noFill/>
-        </p:spPr>
-        <p:txBody>
-          <a:bodyPr wrap="square">
-            <a:spAutoFit/>
-          </a:bodyPr>
-          <a:lstStyle/>
-          <a:p>
-            <a:pPr algn="l">
-              <a:defRPr sz="1300" b="0">
-                <a:solidFill>
-                  <a:srgbClr val="C3CDDC"/>
-                </a:solidFill>
-                <a:latin typeface="Aptos"/>
-              </a:defRPr>
-            </a:pPr>
-            <a:r>
-              <a:t>Curated from the current markdown report</a:t>
-            </a:r>
-          </a:p>
-        </p:txBody>
-      </p:sp>
-      <p:sp>
-        <p:nvSpPr>
-          <p:cNvPr id="6" name="Hexagon 5"/>
+              <a:t>3. Layered Governance Architecture (LGA)</a:t>
+            </a:r>
+          </a:p>
+        </p:txBody>
+      </p:sp>
+      <p:sp>
+        <p:nvSpPr>
+          <p:cNvPr id="5" name="Rounded Rectangle 4"/>
           <p:cNvSpPr/>
           <p:nvPr/>
         </p:nvSpPr>
         <p:spPr>
           <a:xfrm>
-            <a:off x="9509760" y="1645920"/>
-            <a:ext cx="1645920" cy="1645920"/>
-          </a:xfrm>
-          <a:prstGeom prst="hexagon">
+            <a:off x="502920" y="1143000"/>
+            <a:ext cx="11155680" cy="5303520"/>
+          </a:xfrm>
+          <a:prstGeom prst="roundRect">
             <a:avLst/>
           </a:prstGeom>
           <a:solidFill>
-            <a:srgbClr val="A66EFF"/>
+            <a:srgbClr val="18243A"/>
           </a:solidFill>
           <a:ln>
-            <a:noFill/>
+            <a:solidFill>
+              <a:srgbClr val="18243A"/>
+            </a:solidFill>
           </a:ln>
         </p:spPr>
         <p:style>
@@ -4575,6 +4474,109 @@
       </p:sp>
       <p:sp>
         <p:nvSpPr>
+          <p:cNvPr id="6" name="TextBox 5"/>
+          <p:cNvSpPr txBox="1"/>
+          <p:nvPr/>
+        </p:nvSpPr>
+        <p:spPr>
+          <a:xfrm>
+            <a:off x="777240" y="1463040"/>
+            <a:ext cx="10424160" cy="4572000"/>
+          </a:xfrm>
+          <a:prstGeom prst="rect">
+            <a:avLst/>
+          </a:prstGeom>
+          <a:noFill/>
+        </p:spPr>
+        <p:txBody>
+          <a:bodyPr wrap="square">
+            <a:spAutoFit/>
+          </a:bodyPr>
+          <a:lstStyle/>
+          <a:p>
+            <a:pPr>
+              <a:spcAft>
+                <a:spcPts val="1000"/>
+              </a:spcAft>
+              <a:defRPr sz="1600">
+                <a:solidFill>
+                  <a:srgbClr val="C3CDDC"/>
+                </a:solidFill>
+                <a:latin typeface="Aptos"/>
+              </a:defRPr>
+            </a:pPr>
+            <a:r>
+              <a:t>arXiv ID: 2603.07191</a:t>
+            </a:r>
+          </a:p>
+          <a:p>
+            <a:pPr>
+              <a:spcAft>
+                <a:spcPts val="1000"/>
+              </a:spcAft>
+              <a:defRPr sz="1600">
+                <a:solidFill>
+                  <a:srgbClr val="C3CDDC"/>
+                </a:solidFill>
+                <a:latin typeface="Aptos"/>
+              </a:defRPr>
+            </a:pPr>
+            <a:r>
+              <a:t>URL: https://arxiv.org/abs/2603.07191</a:t>
+            </a:r>
+          </a:p>
+          <a:p>
+            <a:pPr>
+              <a:spcAft>
+                <a:spcPts val="1000"/>
+              </a:spcAft>
+              <a:defRPr sz="1600">
+                <a:solidFill>
+                  <a:srgbClr val="C3CDDC"/>
+                </a:solidFill>
+                <a:latin typeface="Aptos"/>
+              </a:defRPr>
+            </a:pPr>
+            <a:r>
+              <a:t>PDF: https://arxiv.org/pdf/2603.07191</a:t>
+            </a:r>
+          </a:p>
+          <a:p>
+            <a:pPr>
+              <a:spcAft>
+                <a:spcPts val="1000"/>
+              </a:spcAft>
+              <a:defRPr sz="1600">
+                <a:solidFill>
+                  <a:srgbClr val="C3CDDC"/>
+                </a:solidFill>
+                <a:latin typeface="Aptos"/>
+              </a:defRPr>
+            </a:pPr>
+            <a:r>
+              <a:t>Authors: Security research team</a:t>
+            </a:r>
+          </a:p>
+          <a:p>
+            <a:pPr>
+              <a:spcAft>
+                <a:spcPts val="1000"/>
+              </a:spcAft>
+              <a:defRPr sz="1600">
+                <a:solidFill>
+                  <a:srgbClr val="C3CDDC"/>
+                </a:solidFill>
+                <a:latin typeface="Aptos"/>
+              </a:defRPr>
+            </a:pPr>
+            <a:r>
+              <a:t>Date: March 2026</a:t>
+            </a:r>
+          </a:p>
+        </p:txBody>
+      </p:sp>
+      <p:sp>
+        <p:nvSpPr>
           <p:cNvPr id="7" name="TextBox 6"/>
           <p:cNvSpPr txBox="1"/>
           <p:nvPr/>
@@ -4598,12 +4600,12 @@
             <a:pPr algn="r">
               <a:defRPr sz="900">
                 <a:solidFill>
-                  <a:srgbClr val="A66EFF"/>
-                </a:solidFill>
-              </a:defRPr>
-            </a:pPr>
-            <a:r>
-              <a:t>Section</a:t>
+                  <a:srgbClr val="3ECFB9"/>
+                </a:solidFill>
+              </a:defRPr>
+            </a:pPr>
+            <a:r>
+              <a:t>EvaPaper</a:t>
             </a:r>
           </a:p>
         </p:txBody>
@@ -4684,7 +4686,7 @@
             <a:avLst/>
           </a:prstGeom>
           <a:solidFill>
-            <a:srgbClr val="A66EFF"/>
+            <a:srgbClr val="3ECFB9"/>
           </a:solidFill>
           <a:ln>
             <a:noFill/>
@@ -4743,7 +4745,7 @@
               </a:defRPr>
             </a:pPr>
             <a:r>
-              <a:t>Layer 0: Spec-Level Governance</a:t>
+              <a:t>4. Skilldex</a:t>
             </a:r>
           </a:p>
         </p:txBody>
@@ -4827,7 +4829,7 @@
               </a:defRPr>
             </a:pPr>
             <a:r>
-              <a:t>Goal: Ensure every skill specification is correct, complete, and safe before it ever reaches an agent.</a:t>
+              <a:t>arXiv ID: 2604.16911</a:t>
             </a:r>
           </a:p>
           <a:p>
@@ -4843,7 +4845,7 @@
               </a:defRPr>
             </a:pPr>
             <a:r>
-              <a:t>Key papers: Skilldex, GovernSpec</a:t>
+              <a:t>URL: https://arxiv.org/abs/2604.16911</a:t>
             </a:r>
           </a:p>
           <a:p>
@@ -4859,7 +4861,7 @@
               </a:defRPr>
             </a:pPr>
             <a:r>
-              <a:t>Key questions:</a:t>
+              <a:t>PDF: https://arxiv.org/pdf/2604.16911</a:t>
             </a:r>
           </a:p>
           <a:p>
@@ -4875,7 +4877,7 @@
               </a:defRPr>
             </a:pPr>
             <a:r>
-              <a:t>Does the skill follow the format specification?</a:t>
+              <a:t>Authors: Skill package research team</a:t>
             </a:r>
           </a:p>
           <a:p>
@@ -4891,7 +4893,7 @@
               </a:defRPr>
             </a:pPr>
             <a:r>
-              <a:t>Are goals, boundaries, and permissions declared?</a:t>
+              <a:t>Date: April 2026</a:t>
             </a:r>
           </a:p>
         </p:txBody>
@@ -4921,7 +4923,7 @@
             <a:pPr algn="r">
               <a:defRPr sz="900">
                 <a:solidFill>
-                  <a:srgbClr val="A66EFF"/>
+                  <a:srgbClr val="3ECFB9"/>
                 </a:solidFill>
               </a:defRPr>
             </a:pPr>
@@ -5043,8 +5045,8 @@
         </p:nvSpPr>
         <p:spPr>
           <a:xfrm>
-            <a:off x="548640" y="384048"/>
-            <a:ext cx="10607040" cy="548640"/>
+            <a:off x="731520" y="2011680"/>
+            <a:ext cx="9601200" cy="914400"/>
           </a:xfrm>
           <a:prstGeom prst="rect">
             <a:avLst/>
@@ -5058,7 +5060,7 @@
           <a:lstStyle/>
           <a:p>
             <a:pPr algn="l">
-              <a:defRPr sz="2200" b="1">
+              <a:defRPr sz="3000" b="1">
                 <a:solidFill>
                   <a:srgbClr val="F5F7FA"/>
                 </a:solidFill>
@@ -5066,32 +5068,66 @@
               </a:defRPr>
             </a:pPr>
             <a:r>
-              <a:t>Layer 1: Runtime-Level Governance</a:t>
-            </a:r>
-          </a:p>
-        </p:txBody>
-      </p:sp>
-      <p:sp>
-        <p:nvSpPr>
-          <p:cNvPr id="5" name="Rounded Rectangle 4"/>
+              <a:t>The Three-Layer Stack in Detail</a:t>
+            </a:r>
+          </a:p>
+        </p:txBody>
+      </p:sp>
+      <p:sp>
+        <p:nvSpPr>
+          <p:cNvPr id="5" name="TextBox 4"/>
+          <p:cNvSpPr txBox="1"/>
+          <p:nvPr/>
+        </p:nvSpPr>
+        <p:spPr>
+          <a:xfrm>
+            <a:off x="749808" y="3063240"/>
+            <a:ext cx="7772400" cy="548640"/>
+          </a:xfrm>
+          <a:prstGeom prst="rect">
+            <a:avLst/>
+          </a:prstGeom>
+          <a:noFill/>
+        </p:spPr>
+        <p:txBody>
+          <a:bodyPr wrap="square">
+            <a:spAutoFit/>
+          </a:bodyPr>
+          <a:lstStyle/>
+          <a:p>
+            <a:pPr algn="l">
+              <a:defRPr sz="1300" b="0">
+                <a:solidFill>
+                  <a:srgbClr val="C3CDDC"/>
+                </a:solidFill>
+                <a:latin typeface="Aptos"/>
+              </a:defRPr>
+            </a:pPr>
+            <a:r>
+              <a:t>Curated from the current markdown report</a:t>
+            </a:r>
+          </a:p>
+        </p:txBody>
+      </p:sp>
+      <p:sp>
+        <p:nvSpPr>
+          <p:cNvPr id="6" name="Hexagon 5"/>
           <p:cNvSpPr/>
           <p:nvPr/>
         </p:nvSpPr>
         <p:spPr>
           <a:xfrm>
-            <a:off x="502920" y="1143000"/>
-            <a:ext cx="11155680" cy="5303520"/>
-          </a:xfrm>
-          <a:prstGeom prst="roundRect">
+            <a:off x="9509760" y="1645920"/>
+            <a:ext cx="1645920" cy="1645920"/>
+          </a:xfrm>
+          <a:prstGeom prst="hexagon">
             <a:avLst/>
           </a:prstGeom>
           <a:solidFill>
-            <a:srgbClr val="18243A"/>
+            <a:srgbClr val="A66EFF"/>
           </a:solidFill>
           <a:ln>
-            <a:solidFill>
-              <a:srgbClr val="18243A"/>
-            </a:solidFill>
+            <a:noFill/>
           </a:ln>
         </p:spPr>
         <p:style>
@@ -5118,109 +5154,6 @@
       </p:sp>
       <p:sp>
         <p:nvSpPr>
-          <p:cNvPr id="6" name="TextBox 5"/>
-          <p:cNvSpPr txBox="1"/>
-          <p:nvPr/>
-        </p:nvSpPr>
-        <p:spPr>
-          <a:xfrm>
-            <a:off x="777240" y="1463040"/>
-            <a:ext cx="10424160" cy="4572000"/>
-          </a:xfrm>
-          <a:prstGeom prst="rect">
-            <a:avLst/>
-          </a:prstGeom>
-          <a:noFill/>
-        </p:spPr>
-        <p:txBody>
-          <a:bodyPr wrap="square">
-            <a:spAutoFit/>
-          </a:bodyPr>
-          <a:lstStyle/>
-          <a:p>
-            <a:pPr>
-              <a:spcAft>
-                <a:spcPts val="1000"/>
-              </a:spcAft>
-              <a:defRPr sz="1600">
-                <a:solidFill>
-                  <a:srgbClr val="C3CDDC"/>
-                </a:solidFill>
-                <a:latin typeface="Aptos"/>
-              </a:defRPr>
-            </a:pPr>
-            <a:r>
-              <a:t>Goal: Ensure every agent execution is sandboxed, verified, authorized, and logged.</a:t>
-            </a:r>
-          </a:p>
-          <a:p>
-            <a:pPr>
-              <a:spcAft>
-                <a:spcPts val="1000"/>
-              </a:spcAft>
-              <a:defRPr sz="1600">
-                <a:solidFill>
-                  <a:srgbClr val="C3CDDC"/>
-                </a:solidFill>
-                <a:latin typeface="Aptos"/>
-              </a:defRPr>
-            </a:pPr>
-            <a:r>
-              <a:t>Key papers: LGA, OWASP (Prompt Injection, Excessive Agency)</a:t>
-            </a:r>
-          </a:p>
-          <a:p>
-            <a:pPr>
-              <a:spcAft>
-                <a:spcPts val="1000"/>
-              </a:spcAft>
-              <a:defRPr sz="1600">
-                <a:solidFill>
-                  <a:srgbClr val="C3CDDC"/>
-                </a:solidFill>
-                <a:latin typeface="Aptos"/>
-              </a:defRPr>
-            </a:pPr>
-            <a:r>
-              <a:t>Key questions:</a:t>
-            </a:r>
-          </a:p>
-          <a:p>
-            <a:pPr>
-              <a:spcAft>
-                <a:spcPts val="1000"/>
-              </a:spcAft>
-              <a:defRPr sz="1600">
-                <a:solidFill>
-                  <a:srgbClr val="C3CDDC"/>
-                </a:solidFill>
-                <a:latin typeface="Aptos"/>
-              </a:defRPr>
-            </a:pPr>
-            <a:r>
-              <a:t>Is the agent executing in a sandbox?</a:t>
-            </a:r>
-          </a:p>
-          <a:p>
-            <a:pPr>
-              <a:spcAft>
-                <a:spcPts val="1000"/>
-              </a:spcAft>
-              <a:defRPr sz="1600">
-                <a:solidFill>
-                  <a:srgbClr val="C3CDDC"/>
-                </a:solidFill>
-                <a:latin typeface="Aptos"/>
-              </a:defRPr>
-            </a:pPr>
-            <a:r>
-              <a:t>Is the intent verified before tool invocation?</a:t>
-            </a:r>
-          </a:p>
-        </p:txBody>
-      </p:sp>
-      <p:sp>
-        <p:nvSpPr>
           <p:cNvPr id="7" name="TextBox 6"/>
           <p:cNvSpPr txBox="1"/>
           <p:nvPr/>
@@ -5249,7 +5182,7 @@
               </a:defRPr>
             </a:pPr>
             <a:r>
-              <a:t>EvaPaper</a:t>
+              <a:t>Section</a:t>
             </a:r>
           </a:p>
         </p:txBody>
@@ -5389,7 +5322,7 @@
               </a:defRPr>
             </a:pPr>
             <a:r>
-              <a:t>Layer 2: Behavioral-Level Governance</a:t>
+              <a:t>Layer 0: Spec-Level Governance</a:t>
             </a:r>
           </a:p>
         </p:txBody>
@@ -5473,7 +5406,7 @@
               </a:defRPr>
             </a:pPr>
             <a:r>
-              <a:t>Goal: Ensure every agent behaves safely and trustworthily in real-world tasks.</a:t>
+              <a:t>Goal: Ensure every skill specification is correct, complete, and safe before it ever reaches an agent.</a:t>
             </a:r>
           </a:p>
           <a:p>
@@ -5489,7 +5422,7 @@
               </a:defRPr>
             </a:pPr>
             <a:r>
-              <a:t>Key papers: BeSafe-Bench, ST-WebAgentBench, Agent Evaluation Guide</a:t>
+              <a:t>Key papers: Skilldex, GovernSpec</a:t>
             </a:r>
           </a:p>
           <a:p>
@@ -5521,7 +5454,7 @@
               </a:defRPr>
             </a:pPr>
             <a:r>
-              <a:t>Does the agent complete tasks while adhering to safety constraints?</a:t>
+              <a:t>Does the skill follow the format specification?</a:t>
             </a:r>
           </a:p>
           <a:p>
@@ -5537,7 +5470,7 @@
               </a:defRPr>
             </a:pPr>
             <a:r>
-              <a:t>Does it violate policies under task pressure?</a:t>
+              <a:t>Are goals, boundaries, and permissions declared?</a:t>
             </a:r>
           </a:p>
         </p:txBody>
@@ -5653,7 +5586,7 @@
             <a:avLst/>
           </a:prstGeom>
           <a:solidFill>
-            <a:srgbClr val="FFB347"/>
+            <a:srgbClr val="A66EFF"/>
           </a:solidFill>
           <a:ln>
             <a:noFill/>
@@ -5689,8 +5622,8 @@
         </p:nvSpPr>
         <p:spPr>
           <a:xfrm>
-            <a:off x="731520" y="2011680"/>
-            <a:ext cx="9601200" cy="914400"/>
+            <a:off x="548640" y="384048"/>
+            <a:ext cx="10607040" cy="548640"/>
           </a:xfrm>
           <a:prstGeom prst="rect">
             <a:avLst/>
@@ -5704,7 +5637,7 @@
           <a:lstStyle/>
           <a:p>
             <a:pPr algn="l">
-              <a:defRPr sz="3000" b="1">
+              <a:defRPr sz="2200" b="1">
                 <a:solidFill>
                   <a:srgbClr val="F5F7FA"/>
                 </a:solidFill>
@@ -5712,66 +5645,32 @@
               </a:defRPr>
             </a:pPr>
             <a:r>
-              <a:t>Implementation Roadmap</a:t>
-            </a:r>
-          </a:p>
-        </p:txBody>
-      </p:sp>
-      <p:sp>
-        <p:nvSpPr>
-          <p:cNvPr id="5" name="TextBox 4"/>
-          <p:cNvSpPr txBox="1"/>
-          <p:nvPr/>
-        </p:nvSpPr>
-        <p:spPr>
-          <a:xfrm>
-            <a:off x="749808" y="3063240"/>
-            <a:ext cx="7772400" cy="548640"/>
-          </a:xfrm>
-          <a:prstGeom prst="rect">
-            <a:avLst/>
-          </a:prstGeom>
-          <a:noFill/>
-        </p:spPr>
-        <p:txBody>
-          <a:bodyPr wrap="square">
-            <a:spAutoFit/>
-          </a:bodyPr>
-          <a:lstStyle/>
-          <a:p>
-            <a:pPr algn="l">
-              <a:defRPr sz="1300" b="0">
-                <a:solidFill>
-                  <a:srgbClr val="C3CDDC"/>
-                </a:solidFill>
-                <a:latin typeface="Aptos"/>
-              </a:defRPr>
-            </a:pPr>
-            <a:r>
-              <a:t>Curated from the current markdown report</a:t>
-            </a:r>
-          </a:p>
-        </p:txBody>
-      </p:sp>
-      <p:sp>
-        <p:nvSpPr>
-          <p:cNvPr id="6" name="Hexagon 5"/>
+              <a:t>Layer 1: Runtime-Level Governance</a:t>
+            </a:r>
+          </a:p>
+        </p:txBody>
+      </p:sp>
+      <p:sp>
+        <p:nvSpPr>
+          <p:cNvPr id="5" name="Rounded Rectangle 4"/>
           <p:cNvSpPr/>
           <p:nvPr/>
         </p:nvSpPr>
         <p:spPr>
           <a:xfrm>
-            <a:off x="9509760" y="1645920"/>
-            <a:ext cx="1645920" cy="1645920"/>
-          </a:xfrm>
-          <a:prstGeom prst="hexagon">
+            <a:off x="502920" y="1143000"/>
+            <a:ext cx="11155680" cy="5303520"/>
+          </a:xfrm>
+          <a:prstGeom prst="roundRect">
             <a:avLst/>
           </a:prstGeom>
           <a:solidFill>
-            <a:srgbClr val="FFB347"/>
+            <a:srgbClr val="18243A"/>
           </a:solidFill>
           <a:ln>
-            <a:noFill/>
+            <a:solidFill>
+              <a:srgbClr val="18243A"/>
+            </a:solidFill>
           </a:ln>
         </p:spPr>
         <p:style>
@@ -5798,6 +5697,109 @@
       </p:sp>
       <p:sp>
         <p:nvSpPr>
+          <p:cNvPr id="6" name="TextBox 5"/>
+          <p:cNvSpPr txBox="1"/>
+          <p:nvPr/>
+        </p:nvSpPr>
+        <p:spPr>
+          <a:xfrm>
+            <a:off x="777240" y="1463040"/>
+            <a:ext cx="10424160" cy="4572000"/>
+          </a:xfrm>
+          <a:prstGeom prst="rect">
+            <a:avLst/>
+          </a:prstGeom>
+          <a:noFill/>
+        </p:spPr>
+        <p:txBody>
+          <a:bodyPr wrap="square">
+            <a:spAutoFit/>
+          </a:bodyPr>
+          <a:lstStyle/>
+          <a:p>
+            <a:pPr>
+              <a:spcAft>
+                <a:spcPts val="1000"/>
+              </a:spcAft>
+              <a:defRPr sz="1600">
+                <a:solidFill>
+                  <a:srgbClr val="C3CDDC"/>
+                </a:solidFill>
+                <a:latin typeface="Aptos"/>
+              </a:defRPr>
+            </a:pPr>
+            <a:r>
+              <a:t>Goal: Ensure every agent execution is sandboxed, verified, authorized, and logged.</a:t>
+            </a:r>
+          </a:p>
+          <a:p>
+            <a:pPr>
+              <a:spcAft>
+                <a:spcPts val="1000"/>
+              </a:spcAft>
+              <a:defRPr sz="1600">
+                <a:solidFill>
+                  <a:srgbClr val="C3CDDC"/>
+                </a:solidFill>
+                <a:latin typeface="Aptos"/>
+              </a:defRPr>
+            </a:pPr>
+            <a:r>
+              <a:t>Key papers: LGA, OWASP (Prompt Injection, Excessive Agency)</a:t>
+            </a:r>
+          </a:p>
+          <a:p>
+            <a:pPr>
+              <a:spcAft>
+                <a:spcPts val="1000"/>
+              </a:spcAft>
+              <a:defRPr sz="1600">
+                <a:solidFill>
+                  <a:srgbClr val="C3CDDC"/>
+                </a:solidFill>
+                <a:latin typeface="Aptos"/>
+              </a:defRPr>
+            </a:pPr>
+            <a:r>
+              <a:t>Key questions:</a:t>
+            </a:r>
+          </a:p>
+          <a:p>
+            <a:pPr>
+              <a:spcAft>
+                <a:spcPts val="1000"/>
+              </a:spcAft>
+              <a:defRPr sz="1600">
+                <a:solidFill>
+                  <a:srgbClr val="C3CDDC"/>
+                </a:solidFill>
+                <a:latin typeface="Aptos"/>
+              </a:defRPr>
+            </a:pPr>
+            <a:r>
+              <a:t>Is the agent executing in a sandbox?</a:t>
+            </a:r>
+          </a:p>
+          <a:p>
+            <a:pPr>
+              <a:spcAft>
+                <a:spcPts val="1000"/>
+              </a:spcAft>
+              <a:defRPr sz="1600">
+                <a:solidFill>
+                  <a:srgbClr val="C3CDDC"/>
+                </a:solidFill>
+                <a:latin typeface="Aptos"/>
+              </a:defRPr>
+            </a:pPr>
+            <a:r>
+              <a:t>Is the intent verified before tool invocation?</a:t>
+            </a:r>
+          </a:p>
+        </p:txBody>
+      </p:sp>
+      <p:sp>
+        <p:nvSpPr>
           <p:cNvPr id="7" name="TextBox 6"/>
           <p:cNvSpPr txBox="1"/>
           <p:nvPr/>
@@ -5821,12 +5823,12 @@
             <a:pPr algn="r">
               <a:defRPr sz="900">
                 <a:solidFill>
-                  <a:srgbClr val="FFB347"/>
-                </a:solidFill>
-              </a:defRPr>
-            </a:pPr>
-            <a:r>
-              <a:t>Section</a:t>
+                  <a:srgbClr val="A66EFF"/>
+                </a:solidFill>
+              </a:defRPr>
+            </a:pPr>
+            <a:r>
+              <a:t>EvaPaper</a:t>
             </a:r>
           </a:p>
         </p:txBody>
@@ -5907,7 +5909,7 @@
             <a:avLst/>
           </a:prstGeom>
           <a:solidFill>
-            <a:srgbClr val="FFB347"/>
+            <a:srgbClr val="A66EFF"/>
           </a:solidFill>
           <a:ln>
             <a:noFill/>
@@ -5966,7 +5968,7 @@
               </a:defRPr>
             </a:pPr>
             <a:r>
-              <a:t>Immediate (30 days)</a:t>
+              <a:t>Layer 2: Behavioral-Level Governance</a:t>
             </a:r>
           </a:p>
         </p:txBody>
@@ -6050,7 +6052,7 @@
               </a:defRPr>
             </a:pPr>
             <a:r>
-              <a:t>Adopt GovernSpec's 12 contract sections for all skill specifications</a:t>
+              <a:t>Goal: Ensure every agent behaves safely and trustworthily in real-world tasks.</a:t>
             </a:r>
           </a:p>
           <a:p>
@@ -6066,7 +6068,7 @@
               </a:defRPr>
             </a:pPr>
             <a:r>
-              <a:t>Deploy Skilldex for validation — check 100% of skill packages</a:t>
+              <a:t>Key papers: BeSafe-Bench, ST-WebAgentBench, Agent Evaluation Guide</a:t>
             </a:r>
           </a:p>
           <a:p>
@@ -6082,7 +6084,39 @@
               </a:defRPr>
             </a:pPr>
             <a:r>
-              <a:t>Map existing skills to OWASP Top 10 — identify which risks are unaddressed</a:t>
+              <a:t>Key questions:</a:t>
+            </a:r>
+          </a:p>
+          <a:p>
+            <a:pPr>
+              <a:spcAft>
+                <a:spcPts val="1000"/>
+              </a:spcAft>
+              <a:defRPr sz="1600">
+                <a:solidFill>
+                  <a:srgbClr val="C3CDDC"/>
+                </a:solidFill>
+                <a:latin typeface="Aptos"/>
+              </a:defRPr>
+            </a:pPr>
+            <a:r>
+              <a:t>Does the agent complete tasks while adhering to safety constraints?</a:t>
+            </a:r>
+          </a:p>
+          <a:p>
+            <a:pPr>
+              <a:spcAft>
+                <a:spcPts val="1000"/>
+              </a:spcAft>
+              <a:defRPr sz="1600">
+                <a:solidFill>
+                  <a:srgbClr val="C3CDDC"/>
+                </a:solidFill>
+                <a:latin typeface="Aptos"/>
+              </a:defRPr>
+            </a:pPr>
+            <a:r>
+              <a:t>Does it violate policies under task pressure?</a:t>
             </a:r>
           </a:p>
         </p:txBody>
@@ -6112,7 +6146,7 @@
             <a:pPr algn="r">
               <a:defRPr sz="900">
                 <a:solidFill>
-                  <a:srgbClr val="FFB347"/>
+                  <a:srgbClr val="A66EFF"/>
                 </a:solidFill>
               </a:defRPr>
             </a:pPr>
@@ -6234,8 +6268,8 @@
         </p:nvSpPr>
         <p:spPr>
           <a:xfrm>
-            <a:off x="548640" y="384048"/>
-            <a:ext cx="10607040" cy="548640"/>
+            <a:off x="731520" y="2011680"/>
+            <a:ext cx="9601200" cy="914400"/>
           </a:xfrm>
           <a:prstGeom prst="rect">
             <a:avLst/>
@@ -6249,7 +6283,7 @@
           <a:lstStyle/>
           <a:p>
             <a:pPr algn="l">
-              <a:defRPr sz="2200" b="1">
+              <a:defRPr sz="3000" b="1">
                 <a:solidFill>
                   <a:srgbClr val="F5F7FA"/>
                 </a:solidFill>
@@ -6257,32 +6291,66 @@
               </a:defRPr>
             </a:pPr>
             <a:r>
-              <a:t>Short-term (90 days)</a:t>
-            </a:r>
-          </a:p>
-        </p:txBody>
-      </p:sp>
-      <p:sp>
-        <p:nvSpPr>
-          <p:cNvPr id="5" name="Rounded Rectangle 4"/>
+              <a:t>Implementation Roadmap</a:t>
+            </a:r>
+          </a:p>
+        </p:txBody>
+      </p:sp>
+      <p:sp>
+        <p:nvSpPr>
+          <p:cNvPr id="5" name="TextBox 4"/>
+          <p:cNvSpPr txBox="1"/>
+          <p:nvPr/>
+        </p:nvSpPr>
+        <p:spPr>
+          <a:xfrm>
+            <a:off x="749808" y="3063240"/>
+            <a:ext cx="7772400" cy="548640"/>
+          </a:xfrm>
+          <a:prstGeom prst="rect">
+            <a:avLst/>
+          </a:prstGeom>
+          <a:noFill/>
+        </p:spPr>
+        <p:txBody>
+          <a:bodyPr wrap="square">
+            <a:spAutoFit/>
+          </a:bodyPr>
+          <a:lstStyle/>
+          <a:p>
+            <a:pPr algn="l">
+              <a:defRPr sz="1300" b="0">
+                <a:solidFill>
+                  <a:srgbClr val="C3CDDC"/>
+                </a:solidFill>
+                <a:latin typeface="Aptos"/>
+              </a:defRPr>
+            </a:pPr>
+            <a:r>
+              <a:t>Curated from the current markdown report</a:t>
+            </a:r>
+          </a:p>
+        </p:txBody>
+      </p:sp>
+      <p:sp>
+        <p:nvSpPr>
+          <p:cNvPr id="6" name="Hexagon 5"/>
           <p:cNvSpPr/>
           <p:nvPr/>
         </p:nvSpPr>
         <p:spPr>
           <a:xfrm>
-            <a:off x="502920" y="1143000"/>
-            <a:ext cx="11155680" cy="5303520"/>
-          </a:xfrm>
-          <a:prstGeom prst="roundRect">
+            <a:off x="9509760" y="1645920"/>
+            <a:ext cx="1645920" cy="1645920"/>
+          </a:xfrm>
+          <a:prstGeom prst="hexagon">
             <a:avLst/>
           </a:prstGeom>
           <a:solidFill>
-            <a:srgbClr val="18243A"/>
+            <a:srgbClr val="FFB347"/>
           </a:solidFill>
           <a:ln>
-            <a:solidFill>
-              <a:srgbClr val="18243A"/>
-            </a:solidFill>
+            <a:noFill/>
           </a:ln>
         </p:spPr>
         <p:style>
@@ -6309,77 +6377,6 @@
       </p:sp>
       <p:sp>
         <p:nvSpPr>
-          <p:cNvPr id="6" name="TextBox 5"/>
-          <p:cNvSpPr txBox="1"/>
-          <p:nvPr/>
-        </p:nvSpPr>
-        <p:spPr>
-          <a:xfrm>
-            <a:off x="777240" y="1463040"/>
-            <a:ext cx="10424160" cy="4572000"/>
-          </a:xfrm>
-          <a:prstGeom prst="rect">
-            <a:avLst/>
-          </a:prstGeom>
-          <a:noFill/>
-        </p:spPr>
-        <p:txBody>
-          <a:bodyPr wrap="square">
-            <a:spAutoFit/>
-          </a:bodyPr>
-          <a:lstStyle/>
-          <a:p>
-            <a:pPr>
-              <a:spcAft>
-                <a:spcPts val="1000"/>
-              </a:spcAft>
-              <a:defRPr sz="1600">
-                <a:solidFill>
-                  <a:srgbClr val="C3CDDC"/>
-                </a:solidFill>
-                <a:latin typeface="Aptos"/>
-              </a:defRPr>
-            </a:pPr>
-            <a:r>
-              <a:t>Implement LGA Layer 1 (sandboxing) for all agent execution</a:t>
-            </a:r>
-          </a:p>
-          <a:p>
-            <a:pPr>
-              <a:spcAft>
-                <a:spcPts val="1000"/>
-              </a:spcAft>
-              <a:defRPr sz="1600">
-                <a:solidFill>
-                  <a:srgbClr val="C3CDDC"/>
-                </a:solidFill>
-                <a:latin typeface="Aptos"/>
-              </a:defRPr>
-            </a:pPr>
-            <a:r>
-              <a:t>Deploy ST-WebAgentBench for web agent evaluation</a:t>
-            </a:r>
-          </a:p>
-          <a:p>
-            <a:pPr>
-              <a:spcAft>
-                <a:spcPts val="1000"/>
-              </a:spcAft>
-              <a:defRPr sz="1600">
-                <a:solidFill>
-                  <a:srgbClr val="C3CDDC"/>
-                </a:solidFill>
-                <a:latin typeface="Aptos"/>
-              </a:defRPr>
-            </a:pPr>
-            <a:r>
-              <a:t>Establish baseline with BeSafe-Bench on current agents</a:t>
-            </a:r>
-          </a:p>
-        </p:txBody>
-      </p:sp>
-      <p:sp>
-        <p:nvSpPr>
           <p:cNvPr id="7" name="TextBox 6"/>
           <p:cNvSpPr txBox="1"/>
           <p:nvPr/>
@@ -6408,7 +6405,7 @@
               </a:defRPr>
             </a:pPr>
             <a:r>
-              <a:t>EvaPaper</a:t>
+              <a:t>Section</a:t>
             </a:r>
           </a:p>
         </p:txBody>
@@ -6887,7 +6884,7 @@
               </a:defRPr>
             </a:pPr>
             <a:r>
-              <a:t>Strategic (12 months)</a:t>
+              <a:t>Immediate (30 days)</a:t>
             </a:r>
           </a:p>
         </p:txBody>
@@ -6971,7 +6968,7 @@
               </a:defRPr>
             </a:pPr>
             <a:r>
-              <a:t>Full LGA stack — all four layers operational</a:t>
+              <a:t>Adopt GovernSpec's 12 contract sections for all skill specifications</a:t>
             </a:r>
           </a:p>
           <a:p>
@@ -6987,7 +6984,7 @@
               </a:defRPr>
             </a:pPr>
             <a:r>
-              <a:t>Microsoft-style governance toolkit — registration, policy, audit, evaluation, human-in-the-loop</a:t>
+              <a:t>Deploy Skilldex for validation — check 100% of skill packages</a:t>
             </a:r>
           </a:p>
           <a:p>
@@ -7003,23 +7000,7 @@
               </a:defRPr>
             </a:pPr>
             <a:r>
-              <a:t>Continuous evaluation — weekly safety benchmarks with automated reporting</a:t>
-            </a:r>
-          </a:p>
-          <a:p>
-            <a:pPr>
-              <a:spcAft>
-                <a:spcPts val="1000"/>
-              </a:spcAft>
-              <a:defRPr sz="1600">
-                <a:solidFill>
-                  <a:srgbClr val="C3CDDC"/>
-                </a:solidFill>
-                <a:latin typeface="Aptos"/>
-              </a:defRPr>
-            </a:pPr>
-            <a:r>
-              <a:t>---</a:t>
+              <a:t>Map existing skills to OWASP Top 10 — identify which risks are unaddressed</a:t>
             </a:r>
           </a:p>
         </p:txBody>
@@ -7135,7 +7116,7 @@
             <a:avLst/>
           </a:prstGeom>
           <a:solidFill>
-            <a:srgbClr val="3F8EFC"/>
+            <a:srgbClr val="FFB347"/>
           </a:solidFill>
           <a:ln>
             <a:noFill/>
@@ -7171,8 +7152,8 @@
         </p:nvSpPr>
         <p:spPr>
           <a:xfrm>
-            <a:off x="731520" y="2011680"/>
-            <a:ext cx="9601200" cy="914400"/>
+            <a:off x="548640" y="384048"/>
+            <a:ext cx="10607040" cy="548640"/>
           </a:xfrm>
           <a:prstGeom prst="rect">
             <a:avLst/>
@@ -7186,7 +7167,7 @@
           <a:lstStyle/>
           <a:p>
             <a:pPr algn="l">
-              <a:defRPr sz="3000" b="1">
+              <a:defRPr sz="2200" b="1">
                 <a:solidFill>
                   <a:srgbClr val="F5F7FA"/>
                 </a:solidFill>
@@ -7194,66 +7175,32 @@
               </a:defRPr>
             </a:pPr>
             <a:r>
-              <a:t>Why This Matters</a:t>
-            </a:r>
-          </a:p>
-        </p:txBody>
-      </p:sp>
-      <p:sp>
-        <p:nvSpPr>
-          <p:cNvPr id="5" name="TextBox 4"/>
-          <p:cNvSpPr txBox="1"/>
-          <p:nvPr/>
-        </p:nvSpPr>
-        <p:spPr>
-          <a:xfrm>
-            <a:off x="749808" y="3063240"/>
-            <a:ext cx="7772400" cy="548640"/>
-          </a:xfrm>
-          <a:prstGeom prst="rect">
-            <a:avLst/>
-          </a:prstGeom>
-          <a:noFill/>
-        </p:spPr>
-        <p:txBody>
-          <a:bodyPr wrap="square">
-            <a:spAutoFit/>
-          </a:bodyPr>
-          <a:lstStyle/>
-          <a:p>
-            <a:pPr algn="l">
-              <a:defRPr sz="1300" b="0">
-                <a:solidFill>
-                  <a:srgbClr val="C3CDDC"/>
-                </a:solidFill>
-                <a:latin typeface="Aptos"/>
-              </a:defRPr>
-            </a:pPr>
-            <a:r>
-              <a:t>Curated from the current markdown report</a:t>
-            </a:r>
-          </a:p>
-        </p:txBody>
-      </p:sp>
-      <p:sp>
-        <p:nvSpPr>
-          <p:cNvPr id="6" name="Hexagon 5"/>
+              <a:t>Short-term (90 days)</a:t>
+            </a:r>
+          </a:p>
+        </p:txBody>
+      </p:sp>
+      <p:sp>
+        <p:nvSpPr>
+          <p:cNvPr id="5" name="Rounded Rectangle 4"/>
           <p:cNvSpPr/>
           <p:nvPr/>
         </p:nvSpPr>
         <p:spPr>
           <a:xfrm>
-            <a:off x="9509760" y="1645920"/>
-            <a:ext cx="1645920" cy="1645920"/>
-          </a:xfrm>
-          <a:prstGeom prst="hexagon">
+            <a:off x="502920" y="1143000"/>
+            <a:ext cx="11155680" cy="5303520"/>
+          </a:xfrm>
+          <a:prstGeom prst="roundRect">
             <a:avLst/>
           </a:prstGeom>
           <a:solidFill>
-            <a:srgbClr val="3F8EFC"/>
+            <a:srgbClr val="18243A"/>
           </a:solidFill>
           <a:ln>
-            <a:noFill/>
+            <a:solidFill>
+              <a:srgbClr val="18243A"/>
+            </a:solidFill>
           </a:ln>
         </p:spPr>
         <p:style>
@@ -7280,6 +7227,77 @@
       </p:sp>
       <p:sp>
         <p:nvSpPr>
+          <p:cNvPr id="6" name="TextBox 5"/>
+          <p:cNvSpPr txBox="1"/>
+          <p:nvPr/>
+        </p:nvSpPr>
+        <p:spPr>
+          <a:xfrm>
+            <a:off x="777240" y="1463040"/>
+            <a:ext cx="10424160" cy="4572000"/>
+          </a:xfrm>
+          <a:prstGeom prst="rect">
+            <a:avLst/>
+          </a:prstGeom>
+          <a:noFill/>
+        </p:spPr>
+        <p:txBody>
+          <a:bodyPr wrap="square">
+            <a:spAutoFit/>
+          </a:bodyPr>
+          <a:lstStyle/>
+          <a:p>
+            <a:pPr>
+              <a:spcAft>
+                <a:spcPts val="1000"/>
+              </a:spcAft>
+              <a:defRPr sz="1600">
+                <a:solidFill>
+                  <a:srgbClr val="C3CDDC"/>
+                </a:solidFill>
+                <a:latin typeface="Aptos"/>
+              </a:defRPr>
+            </a:pPr>
+            <a:r>
+              <a:t>Implement LGA Layer 1 (sandboxing) for all agent execution</a:t>
+            </a:r>
+          </a:p>
+          <a:p>
+            <a:pPr>
+              <a:spcAft>
+                <a:spcPts val="1000"/>
+              </a:spcAft>
+              <a:defRPr sz="1600">
+                <a:solidFill>
+                  <a:srgbClr val="C3CDDC"/>
+                </a:solidFill>
+                <a:latin typeface="Aptos"/>
+              </a:defRPr>
+            </a:pPr>
+            <a:r>
+              <a:t>Deploy ST-WebAgentBench for web agent evaluation</a:t>
+            </a:r>
+          </a:p>
+          <a:p>
+            <a:pPr>
+              <a:spcAft>
+                <a:spcPts val="1000"/>
+              </a:spcAft>
+              <a:defRPr sz="1600">
+                <a:solidFill>
+                  <a:srgbClr val="C3CDDC"/>
+                </a:solidFill>
+                <a:latin typeface="Aptos"/>
+              </a:defRPr>
+            </a:pPr>
+            <a:r>
+              <a:t>Establish baseline with BeSafe-Bench on current agents</a:t>
+            </a:r>
+          </a:p>
+        </p:txBody>
+      </p:sp>
+      <p:sp>
+        <p:nvSpPr>
           <p:cNvPr id="7" name="TextBox 6"/>
           <p:cNvSpPr txBox="1"/>
           <p:nvPr/>
@@ -7303,12 +7321,12 @@
             <a:pPr algn="r">
               <a:defRPr sz="900">
                 <a:solidFill>
-                  <a:srgbClr val="3F8EFC"/>
-                </a:solidFill>
-              </a:defRPr>
-            </a:pPr>
-            <a:r>
-              <a:t>Section</a:t>
+                  <a:srgbClr val="FFB347"/>
+                </a:solidFill>
+              </a:defRPr>
+            </a:pPr>
+            <a:r>
+              <a:t>EvaPaper</a:t>
             </a:r>
           </a:p>
         </p:txBody>
@@ -7389,7 +7407,7 @@
             <a:avLst/>
           </a:prstGeom>
           <a:solidFill>
-            <a:srgbClr val="3F8EFC"/>
+            <a:srgbClr val="FFB347"/>
           </a:solidFill>
           <a:ln>
             <a:noFill/>
@@ -7448,7 +7466,7 @@
               </a:defRPr>
             </a:pPr>
             <a:r>
-              <a:t>Why This Matters</a:t>
+              <a:t>Strategic (12 months)</a:t>
             </a:r>
           </a:p>
         </p:txBody>
@@ -7532,7 +7550,7 @@
               </a:defRPr>
             </a:pPr>
             <a:r>
-              <a:t>The data is clear:</a:t>
+              <a:t>Full LGA stack — all four layers operational</a:t>
             </a:r>
           </a:p>
           <a:p>
@@ -7548,7 +7566,7 @@
               </a:defRPr>
             </a:pPr>
             <a:r>
-              <a:t>34% of community skill packages are malformed (Skilldex)</a:t>
+              <a:t>Microsoft-style governance toolkit — registration, policy, audit, evaluation, human-in-the-loop</a:t>
             </a:r>
           </a:p>
           <a:p>
@@ -7564,7 +7582,7 @@
               </a:defRPr>
             </a:pPr>
             <a:r>
-              <a:t>89% of attacks succeed against baseline guardrails (LGA)</a:t>
+              <a:t>Continuous evaluation — weekly safety benchmarks with automated reporting</a:t>
             </a:r>
           </a:p>
           <a:p>
@@ -7580,23 +7598,7 @@
               </a:defRPr>
             </a:pPr>
             <a:r>
-              <a:t>60%+ of tasks have safety violations (BeSafe-Bench)</a:t>
-            </a:r>
-          </a:p>
-          <a:p>
-            <a:pPr>
-              <a:spcAft>
-                <a:spcPts val="1000"/>
-              </a:spcAft>
-              <a:defRPr sz="1600">
-                <a:solidFill>
-                  <a:srgbClr val="C3CDDC"/>
-                </a:solidFill>
-                <a:latin typeface="Aptos"/>
-              </a:defRPr>
-            </a:pPr>
-            <a:r>
-              <a:t>40% of agent projects face cancellation (Agent Evaluation Guide)</a:t>
+              <a:t>---</a:t>
             </a:r>
           </a:p>
         </p:txBody>
@@ -7626,7 +7628,7 @@
             <a:pPr algn="r">
               <a:defRPr sz="900">
                 <a:solidFill>
-                  <a:srgbClr val="3F8EFC"/>
+                  <a:srgbClr val="FFB347"/>
                 </a:solidFill>
               </a:defRPr>
             </a:pPr>
@@ -7712,7 +7714,7 @@
             <a:avLst/>
           </a:prstGeom>
           <a:solidFill>
-            <a:srgbClr val="3ECFB9"/>
+            <a:srgbClr val="3F8EFC"/>
           </a:solidFill>
           <a:ln>
             <a:noFill/>
@@ -7771,7 +7773,7 @@
               </a:defRPr>
             </a:pPr>
             <a:r>
-              <a:t>Workflow Run Log</a:t>
+              <a:t>Why This Matters</a:t>
             </a:r>
           </a:p>
         </p:txBody>
@@ -7827,7 +7829,7 @@
             <a:avLst/>
           </a:prstGeom>
           <a:solidFill>
-            <a:srgbClr val="3ECFB9"/>
+            <a:srgbClr val="3F8EFC"/>
           </a:solidFill>
           <a:ln>
             <a:noFill/>
@@ -7880,7 +7882,7 @@
             <a:pPr algn="r">
               <a:defRPr sz="900">
                 <a:solidFill>
-                  <a:srgbClr val="3ECFB9"/>
+                  <a:srgbClr val="3F8EFC"/>
                 </a:solidFill>
               </a:defRPr>
             </a:pPr>
@@ -7966,7 +7968,7 @@
             <a:avLst/>
           </a:prstGeom>
           <a:solidFill>
-            <a:srgbClr val="3ECFB9"/>
+            <a:srgbClr val="3F8EFC"/>
           </a:solidFill>
           <a:ln>
             <a:noFill/>
@@ -8025,7 +8027,7 @@
               </a:defRPr>
             </a:pPr>
             <a:r>
-              <a:t>Run 2026-06-07 13:33:31 UTC</a:t>
+              <a:t>Why This Matters</a:t>
             </a:r>
           </a:p>
         </p:txBody>
@@ -8109,7 +8111,7 @@
               </a:defRPr>
             </a:pPr>
             <a:r>
-              <a:t>Mode: static</a:t>
+              <a:t>The data is clear:</a:t>
             </a:r>
           </a:p>
           <a:p>
@@ -8125,7 +8127,7 @@
               </a:defRPr>
             </a:pPr>
             <a:r>
-              <a:t>Query: agent governance skill markdown validation</a:t>
+              <a:t>34% of community skill packages are malformed (Skilldex)</a:t>
             </a:r>
           </a:p>
           <a:p>
@@ -8141,7 +8143,7 @@
               </a:defRPr>
             </a:pPr>
             <a:r>
-              <a:t>Question: which papers are about static checking of agent interactions?</a:t>
+              <a:t>89% of attacks succeed against baseline guardrails (LGA)</a:t>
             </a:r>
           </a:p>
           <a:p>
@@ -8157,7 +8159,7 @@
               </a:defRPr>
             </a:pPr>
             <a:r>
-              <a:t>Discovery graph: 0 seeds, 0 candidates</a:t>
+              <a:t>60%+ of tasks have safety violations (BeSafe-Bench)</a:t>
             </a:r>
           </a:p>
           <a:p>
@@ -8173,7 +8175,7 @@
               </a:defRPr>
             </a:pPr>
             <a:r>
-              <a:t>Input tokens: 1234</a:t>
+              <a:t>40% of agent projects face cancellation (Agent Evaluation Guide)</a:t>
             </a:r>
           </a:p>
         </p:txBody>
@@ -8203,7 +8205,7 @@
             <a:pPr algn="r">
               <a:defRPr sz="900">
                 <a:solidFill>
-                  <a:srgbClr val="3ECFB9"/>
+                  <a:srgbClr val="3F8EFC"/>
                 </a:solidFill>
               </a:defRPr>
             </a:pPr>
@@ -8325,8 +8327,8 @@
         </p:nvSpPr>
         <p:spPr>
           <a:xfrm>
-            <a:off x="548640" y="384048"/>
-            <a:ext cx="10607040" cy="548640"/>
+            <a:off x="731520" y="2011680"/>
+            <a:ext cx="9601200" cy="914400"/>
           </a:xfrm>
           <a:prstGeom prst="rect">
             <a:avLst/>
@@ -8340,7 +8342,7 @@
           <a:lstStyle/>
           <a:p>
             <a:pPr algn="l">
-              <a:defRPr sz="2200" b="1">
+              <a:defRPr sz="3000" b="1">
                 <a:solidFill>
                   <a:srgbClr val="F5F7FA"/>
                 </a:solidFill>
@@ -8348,32 +8350,66 @@
               </a:defRPr>
             </a:pPr>
             <a:r>
-              <a:t>Run 2026-06-07 13:35:24 UTC</a:t>
-            </a:r>
-          </a:p>
-        </p:txBody>
-      </p:sp>
-      <p:sp>
-        <p:nvSpPr>
-          <p:cNvPr id="5" name="Rounded Rectangle 4"/>
+              <a:t>Workflow Run Log</a:t>
+            </a:r>
+          </a:p>
+        </p:txBody>
+      </p:sp>
+      <p:sp>
+        <p:nvSpPr>
+          <p:cNvPr id="5" name="TextBox 4"/>
+          <p:cNvSpPr txBox="1"/>
+          <p:nvPr/>
+        </p:nvSpPr>
+        <p:spPr>
+          <a:xfrm>
+            <a:off x="749808" y="3063240"/>
+            <a:ext cx="7772400" cy="548640"/>
+          </a:xfrm>
+          <a:prstGeom prst="rect">
+            <a:avLst/>
+          </a:prstGeom>
+          <a:noFill/>
+        </p:spPr>
+        <p:txBody>
+          <a:bodyPr wrap="square">
+            <a:spAutoFit/>
+          </a:bodyPr>
+          <a:lstStyle/>
+          <a:p>
+            <a:pPr algn="l">
+              <a:defRPr sz="1300" b="0">
+                <a:solidFill>
+                  <a:srgbClr val="C3CDDC"/>
+                </a:solidFill>
+                <a:latin typeface="Aptos"/>
+              </a:defRPr>
+            </a:pPr>
+            <a:r>
+              <a:t>Curated from the current markdown report</a:t>
+            </a:r>
+          </a:p>
+        </p:txBody>
+      </p:sp>
+      <p:sp>
+        <p:nvSpPr>
+          <p:cNvPr id="6" name="Hexagon 5"/>
           <p:cNvSpPr/>
           <p:nvPr/>
         </p:nvSpPr>
         <p:spPr>
           <a:xfrm>
-            <a:off x="502920" y="1143000"/>
-            <a:ext cx="11155680" cy="5303520"/>
-          </a:xfrm>
-          <a:prstGeom prst="roundRect">
+            <a:off x="9509760" y="1645920"/>
+            <a:ext cx="1645920" cy="1645920"/>
+          </a:xfrm>
+          <a:prstGeom prst="hexagon">
             <a:avLst/>
           </a:prstGeom>
           <a:solidFill>
-            <a:srgbClr val="18243A"/>
+            <a:srgbClr val="3ECFB9"/>
           </a:solidFill>
           <a:ln>
-            <a:solidFill>
-              <a:srgbClr val="18243A"/>
-            </a:solidFill>
+            <a:noFill/>
           </a:ln>
         </p:spPr>
         <p:style>
@@ -8400,109 +8436,6 @@
       </p:sp>
       <p:sp>
         <p:nvSpPr>
-          <p:cNvPr id="6" name="TextBox 5"/>
-          <p:cNvSpPr txBox="1"/>
-          <p:nvPr/>
-        </p:nvSpPr>
-        <p:spPr>
-          <a:xfrm>
-            <a:off x="777240" y="1463040"/>
-            <a:ext cx="10424160" cy="4572000"/>
-          </a:xfrm>
-          <a:prstGeom prst="rect">
-            <a:avLst/>
-          </a:prstGeom>
-          <a:noFill/>
-        </p:spPr>
-        <p:txBody>
-          <a:bodyPr wrap="square">
-            <a:spAutoFit/>
-          </a:bodyPr>
-          <a:lstStyle/>
-          <a:p>
-            <a:pPr>
-              <a:spcAft>
-                <a:spcPts val="1000"/>
-              </a:spcAft>
-              <a:defRPr sz="1600">
-                <a:solidFill>
-                  <a:srgbClr val="C3CDDC"/>
-                </a:solidFill>
-                <a:latin typeface="Aptos"/>
-              </a:defRPr>
-            </a:pPr>
-            <a:r>
-              <a:t>Mode: static</a:t>
-            </a:r>
-          </a:p>
-          <a:p>
-            <a:pPr>
-              <a:spcAft>
-                <a:spcPts val="1000"/>
-              </a:spcAft>
-              <a:defRPr sz="1600">
-                <a:solidFill>
-                  <a:srgbClr val="C3CDDC"/>
-                </a:solidFill>
-                <a:latin typeface="Aptos"/>
-              </a:defRPr>
-            </a:pPr>
-            <a:r>
-              <a:t>Query: agent governance skill markdown validation</a:t>
-            </a:r>
-          </a:p>
-          <a:p>
-            <a:pPr>
-              <a:spcAft>
-                <a:spcPts val="1000"/>
-              </a:spcAft>
-              <a:defRPr sz="1600">
-                <a:solidFill>
-                  <a:srgbClr val="C3CDDC"/>
-                </a:solidFill>
-                <a:latin typeface="Aptos"/>
-              </a:defRPr>
-            </a:pPr>
-            <a:r>
-              <a:t>Question: which papers are about static checking of agent interactions?</a:t>
-            </a:r>
-          </a:p>
-          <a:p>
-            <a:pPr>
-              <a:spcAft>
-                <a:spcPts val="1000"/>
-              </a:spcAft>
-              <a:defRPr sz="1600">
-                <a:solidFill>
-                  <a:srgbClr val="C3CDDC"/>
-                </a:solidFill>
-                <a:latin typeface="Aptos"/>
-              </a:defRPr>
-            </a:pPr>
-            <a:r>
-              <a:t>Discovery graph: 0 seeds, 0 candidates</a:t>
-            </a:r>
-          </a:p>
-          <a:p>
-            <a:pPr>
-              <a:spcAft>
-                <a:spcPts val="1000"/>
-              </a:spcAft>
-              <a:defRPr sz="1600">
-                <a:solidFill>
-                  <a:srgbClr val="C3CDDC"/>
-                </a:solidFill>
-                <a:latin typeface="Aptos"/>
-              </a:defRPr>
-            </a:pPr>
-            <a:r>
-              <a:t>Input tokens: 0</a:t>
-            </a:r>
-          </a:p>
-        </p:txBody>
-      </p:sp>
-      <p:sp>
-        <p:nvSpPr>
           <p:cNvPr id="7" name="TextBox 6"/>
           <p:cNvSpPr txBox="1"/>
           <p:nvPr/>
@@ -8531,7 +8464,7 @@
               </a:defRPr>
             </a:pPr>
             <a:r>
-              <a:t>EvaPaper</a:t>
+              <a:t>Section</a:t>
             </a:r>
           </a:p>
         </p:txBody>
@@ -8671,6 +8604,652 @@
               </a:defRPr>
             </a:pPr>
             <a:r>
+              <a:t>Run 2026-06-07 13:33:31 UTC</a:t>
+            </a:r>
+          </a:p>
+        </p:txBody>
+      </p:sp>
+      <p:sp>
+        <p:nvSpPr>
+          <p:cNvPr id="5" name="Rounded Rectangle 4"/>
+          <p:cNvSpPr/>
+          <p:nvPr/>
+        </p:nvSpPr>
+        <p:spPr>
+          <a:xfrm>
+            <a:off x="502920" y="1143000"/>
+            <a:ext cx="11155680" cy="5303520"/>
+          </a:xfrm>
+          <a:prstGeom prst="roundRect">
+            <a:avLst/>
+          </a:prstGeom>
+          <a:solidFill>
+            <a:srgbClr val="18243A"/>
+          </a:solidFill>
+          <a:ln>
+            <a:solidFill>
+              <a:srgbClr val="18243A"/>
+            </a:solidFill>
+          </a:ln>
+        </p:spPr>
+        <p:style>
+          <a:lnRef idx="1">
+            <a:schemeClr val="accent1"/>
+          </a:lnRef>
+          <a:fillRef idx="3">
+            <a:schemeClr val="accent1"/>
+          </a:fillRef>
+          <a:effectRef idx="2">
+            <a:schemeClr val="accent1"/>
+          </a:effectRef>
+          <a:fontRef idx="minor">
+            <a:schemeClr val="lt1"/>
+          </a:fontRef>
+        </p:style>
+        <p:txBody>
+          <a:bodyPr rtlCol="0" anchor="ctr"/>
+          <a:lstStyle/>
+          <a:p>
+            <a:pPr algn="ctr"/>
+          </a:p>
+        </p:txBody>
+      </p:sp>
+      <p:sp>
+        <p:nvSpPr>
+          <p:cNvPr id="6" name="TextBox 5"/>
+          <p:cNvSpPr txBox="1"/>
+          <p:nvPr/>
+        </p:nvSpPr>
+        <p:spPr>
+          <a:xfrm>
+            <a:off x="777240" y="1463040"/>
+            <a:ext cx="10424160" cy="4572000"/>
+          </a:xfrm>
+          <a:prstGeom prst="rect">
+            <a:avLst/>
+          </a:prstGeom>
+          <a:noFill/>
+        </p:spPr>
+        <p:txBody>
+          <a:bodyPr wrap="square">
+            <a:spAutoFit/>
+          </a:bodyPr>
+          <a:lstStyle/>
+          <a:p>
+            <a:pPr>
+              <a:spcAft>
+                <a:spcPts val="1000"/>
+              </a:spcAft>
+              <a:defRPr sz="1600">
+                <a:solidFill>
+                  <a:srgbClr val="C3CDDC"/>
+                </a:solidFill>
+                <a:latin typeface="Aptos"/>
+              </a:defRPr>
+            </a:pPr>
+            <a:r>
+              <a:t>Mode: static</a:t>
+            </a:r>
+          </a:p>
+          <a:p>
+            <a:pPr>
+              <a:spcAft>
+                <a:spcPts val="1000"/>
+              </a:spcAft>
+              <a:defRPr sz="1600">
+                <a:solidFill>
+                  <a:srgbClr val="C3CDDC"/>
+                </a:solidFill>
+                <a:latin typeface="Aptos"/>
+              </a:defRPr>
+            </a:pPr>
+            <a:r>
+              <a:t>Query: agent governance skill markdown validation</a:t>
+            </a:r>
+          </a:p>
+          <a:p>
+            <a:pPr>
+              <a:spcAft>
+                <a:spcPts val="1000"/>
+              </a:spcAft>
+              <a:defRPr sz="1600">
+                <a:solidFill>
+                  <a:srgbClr val="C3CDDC"/>
+                </a:solidFill>
+                <a:latin typeface="Aptos"/>
+              </a:defRPr>
+            </a:pPr>
+            <a:r>
+              <a:t>Question: which papers are about static checking of agent interactions?</a:t>
+            </a:r>
+          </a:p>
+          <a:p>
+            <a:pPr>
+              <a:spcAft>
+                <a:spcPts val="1000"/>
+              </a:spcAft>
+              <a:defRPr sz="1600">
+                <a:solidFill>
+                  <a:srgbClr val="C3CDDC"/>
+                </a:solidFill>
+                <a:latin typeface="Aptos"/>
+              </a:defRPr>
+            </a:pPr>
+            <a:r>
+              <a:t>Discovery graph: 0 seeds, 0 candidates</a:t>
+            </a:r>
+          </a:p>
+          <a:p>
+            <a:pPr>
+              <a:spcAft>
+                <a:spcPts val="1000"/>
+              </a:spcAft>
+              <a:defRPr sz="1600">
+                <a:solidFill>
+                  <a:srgbClr val="C3CDDC"/>
+                </a:solidFill>
+                <a:latin typeface="Aptos"/>
+              </a:defRPr>
+            </a:pPr>
+            <a:r>
+              <a:t>Input tokens: 1234</a:t>
+            </a:r>
+          </a:p>
+        </p:txBody>
+      </p:sp>
+      <p:sp>
+        <p:nvSpPr>
+          <p:cNvPr id="7" name="TextBox 6"/>
+          <p:cNvSpPr txBox="1"/>
+          <p:nvPr/>
+        </p:nvSpPr>
+        <p:spPr>
+          <a:xfrm>
+            <a:off x="457200" y="6400800"/>
+            <a:ext cx="11155680" cy="228600"/>
+          </a:xfrm>
+          <a:prstGeom prst="rect">
+            <a:avLst/>
+          </a:prstGeom>
+          <a:noFill/>
+        </p:spPr>
+        <p:txBody>
+          <a:bodyPr wrap="none">
+            <a:spAutoFit/>
+          </a:bodyPr>
+          <a:lstStyle/>
+          <a:p>
+            <a:pPr algn="r">
+              <a:defRPr sz="900">
+                <a:solidFill>
+                  <a:srgbClr val="3ECFB9"/>
+                </a:solidFill>
+              </a:defRPr>
+            </a:pPr>
+            <a:r>
+              <a:t>EvaPaper</a:t>
+            </a:r>
+          </a:p>
+        </p:txBody>
+      </p:sp>
+    </p:spTree>
+  </p:cSld>
+  <p:clrMapOvr>
+    <a:masterClrMapping/>
+  </p:clrMapOvr>
+</p:sld>
+</file>
+
+<file path=ppt/slides/slide27.xml><?xml version="1.0" encoding="utf-8"?>
+<p:sld xmlns:a="http://schemas.openxmlformats.org/drawingml/2006/main" xmlns:p="http://schemas.openxmlformats.org/presentationml/2006/main" xmlns:r="http://schemas.openxmlformats.org/officeDocument/2006/relationships">
+  <p:cSld>
+    <p:spTree>
+      <p:nvGrpSpPr>
+        <p:cNvPr id="1" name=""/>
+        <p:cNvGrpSpPr/>
+        <p:nvPr/>
+      </p:nvGrpSpPr>
+      <p:grpSpPr/>
+      <p:sp>
+        <p:nvSpPr>
+          <p:cNvPr id="2" name="Rectangle 1"/>
+          <p:cNvSpPr/>
+          <p:nvPr/>
+        </p:nvSpPr>
+        <p:spPr>
+          <a:xfrm>
+            <a:off x="0" y="0"/>
+            <a:ext cx="12191695" cy="6858000"/>
+          </a:xfrm>
+          <a:prstGeom prst="rect">
+            <a:avLst/>
+          </a:prstGeom>
+          <a:solidFill>
+            <a:srgbClr val="0C1321"/>
+          </a:solidFill>
+          <a:ln>
+            <a:noFill/>
+          </a:ln>
+        </p:spPr>
+        <p:style>
+          <a:lnRef idx="1">
+            <a:schemeClr val="accent1"/>
+          </a:lnRef>
+          <a:fillRef idx="3">
+            <a:schemeClr val="accent1"/>
+          </a:fillRef>
+          <a:effectRef idx="2">
+            <a:schemeClr val="accent1"/>
+          </a:effectRef>
+          <a:fontRef idx="minor">
+            <a:schemeClr val="lt1"/>
+          </a:fontRef>
+        </p:style>
+        <p:txBody>
+          <a:bodyPr rtlCol="0" anchor="ctr"/>
+          <a:lstStyle/>
+          <a:p>
+            <a:pPr algn="ctr"/>
+          </a:p>
+        </p:txBody>
+      </p:sp>
+      <p:sp>
+        <p:nvSpPr>
+          <p:cNvPr id="3" name="Rectangle 2"/>
+          <p:cNvSpPr/>
+          <p:nvPr/>
+        </p:nvSpPr>
+        <p:spPr>
+          <a:xfrm>
+            <a:off x="0" y="0"/>
+            <a:ext cx="12191695" cy="109728"/>
+          </a:xfrm>
+          <a:prstGeom prst="rect">
+            <a:avLst/>
+          </a:prstGeom>
+          <a:solidFill>
+            <a:srgbClr val="3ECFB9"/>
+          </a:solidFill>
+          <a:ln>
+            <a:noFill/>
+          </a:ln>
+        </p:spPr>
+        <p:style>
+          <a:lnRef idx="1">
+            <a:schemeClr val="accent1"/>
+          </a:lnRef>
+          <a:fillRef idx="3">
+            <a:schemeClr val="accent1"/>
+          </a:fillRef>
+          <a:effectRef idx="2">
+            <a:schemeClr val="accent1"/>
+          </a:effectRef>
+          <a:fontRef idx="minor">
+            <a:schemeClr val="lt1"/>
+          </a:fontRef>
+        </p:style>
+        <p:txBody>
+          <a:bodyPr rtlCol="0" anchor="ctr"/>
+          <a:lstStyle/>
+          <a:p>
+            <a:pPr algn="ctr"/>
+          </a:p>
+        </p:txBody>
+      </p:sp>
+      <p:sp>
+        <p:nvSpPr>
+          <p:cNvPr id="4" name="TextBox 3"/>
+          <p:cNvSpPr txBox="1"/>
+          <p:nvPr/>
+        </p:nvSpPr>
+        <p:spPr>
+          <a:xfrm>
+            <a:off x="548640" y="384048"/>
+            <a:ext cx="10607040" cy="548640"/>
+          </a:xfrm>
+          <a:prstGeom prst="rect">
+            <a:avLst/>
+          </a:prstGeom>
+          <a:noFill/>
+        </p:spPr>
+        <p:txBody>
+          <a:bodyPr wrap="square">
+            <a:spAutoFit/>
+          </a:bodyPr>
+          <a:lstStyle/>
+          <a:p>
+            <a:pPr algn="l">
+              <a:defRPr sz="2200" b="1">
+                <a:solidFill>
+                  <a:srgbClr val="F5F7FA"/>
+                </a:solidFill>
+                <a:latin typeface="Aptos"/>
+              </a:defRPr>
+            </a:pPr>
+            <a:r>
+              <a:t>Run 2026-06-07 13:35:24 UTC</a:t>
+            </a:r>
+          </a:p>
+        </p:txBody>
+      </p:sp>
+      <p:sp>
+        <p:nvSpPr>
+          <p:cNvPr id="5" name="Rounded Rectangle 4"/>
+          <p:cNvSpPr/>
+          <p:nvPr/>
+        </p:nvSpPr>
+        <p:spPr>
+          <a:xfrm>
+            <a:off x="502920" y="1143000"/>
+            <a:ext cx="11155680" cy="5303520"/>
+          </a:xfrm>
+          <a:prstGeom prst="roundRect">
+            <a:avLst/>
+          </a:prstGeom>
+          <a:solidFill>
+            <a:srgbClr val="18243A"/>
+          </a:solidFill>
+          <a:ln>
+            <a:solidFill>
+              <a:srgbClr val="18243A"/>
+            </a:solidFill>
+          </a:ln>
+        </p:spPr>
+        <p:style>
+          <a:lnRef idx="1">
+            <a:schemeClr val="accent1"/>
+          </a:lnRef>
+          <a:fillRef idx="3">
+            <a:schemeClr val="accent1"/>
+          </a:fillRef>
+          <a:effectRef idx="2">
+            <a:schemeClr val="accent1"/>
+          </a:effectRef>
+          <a:fontRef idx="minor">
+            <a:schemeClr val="lt1"/>
+          </a:fontRef>
+        </p:style>
+        <p:txBody>
+          <a:bodyPr rtlCol="0" anchor="ctr"/>
+          <a:lstStyle/>
+          <a:p>
+            <a:pPr algn="ctr"/>
+          </a:p>
+        </p:txBody>
+      </p:sp>
+      <p:sp>
+        <p:nvSpPr>
+          <p:cNvPr id="6" name="TextBox 5"/>
+          <p:cNvSpPr txBox="1"/>
+          <p:nvPr/>
+        </p:nvSpPr>
+        <p:spPr>
+          <a:xfrm>
+            <a:off x="777240" y="1463040"/>
+            <a:ext cx="10424160" cy="4572000"/>
+          </a:xfrm>
+          <a:prstGeom prst="rect">
+            <a:avLst/>
+          </a:prstGeom>
+          <a:noFill/>
+        </p:spPr>
+        <p:txBody>
+          <a:bodyPr wrap="square">
+            <a:spAutoFit/>
+          </a:bodyPr>
+          <a:lstStyle/>
+          <a:p>
+            <a:pPr>
+              <a:spcAft>
+                <a:spcPts val="1000"/>
+              </a:spcAft>
+              <a:defRPr sz="1600">
+                <a:solidFill>
+                  <a:srgbClr val="C3CDDC"/>
+                </a:solidFill>
+                <a:latin typeface="Aptos"/>
+              </a:defRPr>
+            </a:pPr>
+            <a:r>
+              <a:t>Mode: static</a:t>
+            </a:r>
+          </a:p>
+          <a:p>
+            <a:pPr>
+              <a:spcAft>
+                <a:spcPts val="1000"/>
+              </a:spcAft>
+              <a:defRPr sz="1600">
+                <a:solidFill>
+                  <a:srgbClr val="C3CDDC"/>
+                </a:solidFill>
+                <a:latin typeface="Aptos"/>
+              </a:defRPr>
+            </a:pPr>
+            <a:r>
+              <a:t>Query: agent governance skill markdown validation</a:t>
+            </a:r>
+          </a:p>
+          <a:p>
+            <a:pPr>
+              <a:spcAft>
+                <a:spcPts val="1000"/>
+              </a:spcAft>
+              <a:defRPr sz="1600">
+                <a:solidFill>
+                  <a:srgbClr val="C3CDDC"/>
+                </a:solidFill>
+                <a:latin typeface="Aptos"/>
+              </a:defRPr>
+            </a:pPr>
+            <a:r>
+              <a:t>Question: which papers are about static checking of agent interactions?</a:t>
+            </a:r>
+          </a:p>
+          <a:p>
+            <a:pPr>
+              <a:spcAft>
+                <a:spcPts val="1000"/>
+              </a:spcAft>
+              <a:defRPr sz="1600">
+                <a:solidFill>
+                  <a:srgbClr val="C3CDDC"/>
+                </a:solidFill>
+                <a:latin typeface="Aptos"/>
+              </a:defRPr>
+            </a:pPr>
+            <a:r>
+              <a:t>Discovery graph: 0 seeds, 0 candidates</a:t>
+            </a:r>
+          </a:p>
+          <a:p>
+            <a:pPr>
+              <a:spcAft>
+                <a:spcPts val="1000"/>
+              </a:spcAft>
+              <a:defRPr sz="1600">
+                <a:solidFill>
+                  <a:srgbClr val="C3CDDC"/>
+                </a:solidFill>
+                <a:latin typeface="Aptos"/>
+              </a:defRPr>
+            </a:pPr>
+            <a:r>
+              <a:t>Input tokens: 0</a:t>
+            </a:r>
+          </a:p>
+        </p:txBody>
+      </p:sp>
+      <p:sp>
+        <p:nvSpPr>
+          <p:cNvPr id="7" name="TextBox 6"/>
+          <p:cNvSpPr txBox="1"/>
+          <p:nvPr/>
+        </p:nvSpPr>
+        <p:spPr>
+          <a:xfrm>
+            <a:off x="457200" y="6400800"/>
+            <a:ext cx="11155680" cy="228600"/>
+          </a:xfrm>
+          <a:prstGeom prst="rect">
+            <a:avLst/>
+          </a:prstGeom>
+          <a:noFill/>
+        </p:spPr>
+        <p:txBody>
+          <a:bodyPr wrap="none">
+            <a:spAutoFit/>
+          </a:bodyPr>
+          <a:lstStyle/>
+          <a:p>
+            <a:pPr algn="r">
+              <a:defRPr sz="900">
+                <a:solidFill>
+                  <a:srgbClr val="3ECFB9"/>
+                </a:solidFill>
+              </a:defRPr>
+            </a:pPr>
+            <a:r>
+              <a:t>EvaPaper</a:t>
+            </a:r>
+          </a:p>
+        </p:txBody>
+      </p:sp>
+    </p:spTree>
+  </p:cSld>
+  <p:clrMapOvr>
+    <a:masterClrMapping/>
+  </p:clrMapOvr>
+</p:sld>
+</file>
+
+<file path=ppt/slides/slide28.xml><?xml version="1.0" encoding="utf-8"?>
+<p:sld xmlns:a="http://schemas.openxmlformats.org/drawingml/2006/main" xmlns:p="http://schemas.openxmlformats.org/presentationml/2006/main" xmlns:r="http://schemas.openxmlformats.org/officeDocument/2006/relationships">
+  <p:cSld>
+    <p:spTree>
+      <p:nvGrpSpPr>
+        <p:cNvPr id="1" name=""/>
+        <p:cNvGrpSpPr/>
+        <p:nvPr/>
+      </p:nvGrpSpPr>
+      <p:grpSpPr/>
+      <p:sp>
+        <p:nvSpPr>
+          <p:cNvPr id="2" name="Rectangle 1"/>
+          <p:cNvSpPr/>
+          <p:nvPr/>
+        </p:nvSpPr>
+        <p:spPr>
+          <a:xfrm>
+            <a:off x="0" y="0"/>
+            <a:ext cx="12191695" cy="6858000"/>
+          </a:xfrm>
+          <a:prstGeom prst="rect">
+            <a:avLst/>
+          </a:prstGeom>
+          <a:solidFill>
+            <a:srgbClr val="0C1321"/>
+          </a:solidFill>
+          <a:ln>
+            <a:noFill/>
+          </a:ln>
+        </p:spPr>
+        <p:style>
+          <a:lnRef idx="1">
+            <a:schemeClr val="accent1"/>
+          </a:lnRef>
+          <a:fillRef idx="3">
+            <a:schemeClr val="accent1"/>
+          </a:fillRef>
+          <a:effectRef idx="2">
+            <a:schemeClr val="accent1"/>
+          </a:effectRef>
+          <a:fontRef idx="minor">
+            <a:schemeClr val="lt1"/>
+          </a:fontRef>
+        </p:style>
+        <p:txBody>
+          <a:bodyPr rtlCol="0" anchor="ctr"/>
+          <a:lstStyle/>
+          <a:p>
+            <a:pPr algn="ctr"/>
+          </a:p>
+        </p:txBody>
+      </p:sp>
+      <p:sp>
+        <p:nvSpPr>
+          <p:cNvPr id="3" name="Rectangle 2"/>
+          <p:cNvSpPr/>
+          <p:nvPr/>
+        </p:nvSpPr>
+        <p:spPr>
+          <a:xfrm>
+            <a:off x="0" y="0"/>
+            <a:ext cx="12191695" cy="109728"/>
+          </a:xfrm>
+          <a:prstGeom prst="rect">
+            <a:avLst/>
+          </a:prstGeom>
+          <a:solidFill>
+            <a:srgbClr val="3ECFB9"/>
+          </a:solidFill>
+          <a:ln>
+            <a:noFill/>
+          </a:ln>
+        </p:spPr>
+        <p:style>
+          <a:lnRef idx="1">
+            <a:schemeClr val="accent1"/>
+          </a:lnRef>
+          <a:fillRef idx="3">
+            <a:schemeClr val="accent1"/>
+          </a:fillRef>
+          <a:effectRef idx="2">
+            <a:schemeClr val="accent1"/>
+          </a:effectRef>
+          <a:fontRef idx="minor">
+            <a:schemeClr val="lt1"/>
+          </a:fontRef>
+        </p:style>
+        <p:txBody>
+          <a:bodyPr rtlCol="0" anchor="ctr"/>
+          <a:lstStyle/>
+          <a:p>
+            <a:pPr algn="ctr"/>
+          </a:p>
+        </p:txBody>
+      </p:sp>
+      <p:sp>
+        <p:nvSpPr>
+          <p:cNvPr id="4" name="TextBox 3"/>
+          <p:cNvSpPr txBox="1"/>
+          <p:nvPr/>
+        </p:nvSpPr>
+        <p:spPr>
+          <a:xfrm>
+            <a:off x="548640" y="384048"/>
+            <a:ext cx="10607040" cy="548640"/>
+          </a:xfrm>
+          <a:prstGeom prst="rect">
+            <a:avLst/>
+          </a:prstGeom>
+          <a:noFill/>
+        </p:spPr>
+        <p:txBody>
+          <a:bodyPr wrap="square">
+            <a:spAutoFit/>
+          </a:bodyPr>
+          <a:lstStyle/>
+          <a:p>
+            <a:pPr algn="l">
+              <a:defRPr sz="2200" b="1">
+                <a:solidFill>
+                  <a:srgbClr val="F5F7FA"/>
+                </a:solidFill>
+                <a:latin typeface="Aptos"/>
+              </a:defRPr>
+            </a:pPr>
+            <a:r>
               <a:t>Run 2026-06-07 13:52:47 UTC</a:t>
             </a:r>
           </a:p>
@@ -9757,7 +10336,7 @@
               </a:defRPr>
             </a:pPr>
             <a:r>
-              <a:t>SkillSafetyBench (arXiv:2605.12015)</a:t>
+              <a:t>EmbodiedGovBench (arXiv:2604.11174)</a:t>
             </a:r>
           </a:p>
           <a:p>
@@ -9773,71 +10352,7 @@
               </a:defRPr>
             </a:pPr>
             <a:r>
-              <a:t>Measuring Compositional Risk (arXiv:2606.00448)</a:t>
-            </a:r>
-          </a:p>
-          <a:p>
-            <a:pPr>
-              <a:spcAft>
-                <a:spcPts val="1000"/>
-              </a:spcAft>
-              <a:defRPr sz="1800">
-                <a:solidFill>
-                  <a:srgbClr val="C3CDDC"/>
-                </a:solidFill>
-                <a:latin typeface="Aptos"/>
-              </a:defRPr>
-            </a:pPr>
-            <a:r>
-              <a:t>AgentTrap (arXiv:2605.13940)</a:t>
-            </a:r>
-          </a:p>
-          <a:p>
-            <a:pPr>
-              <a:spcAft>
-                <a:spcPts val="1000"/>
-              </a:spcAft>
-              <a:defRPr sz="1800">
-                <a:solidFill>
-                  <a:srgbClr val="C3CDDC"/>
-                </a:solidFill>
-                <a:latin typeface="Aptos"/>
-              </a:defRPr>
-            </a:pPr>
-            <a:r>
-              <a:t>Skill-as-Pseudocode (SaP) (arXiv:2605.27955)</a:t>
-            </a:r>
-          </a:p>
-          <a:p>
-            <a:pPr>
-              <a:spcAft>
-                <a:spcPts val="1000"/>
-              </a:spcAft>
-              <a:defRPr sz="1800">
-                <a:solidFill>
-                  <a:srgbClr val="C3CDDC"/>
-                </a:solidFill>
-                <a:latin typeface="Aptos"/>
-              </a:defRPr>
-            </a:pPr>
-            <a:r>
-              <a:t>KYA (arXiv:2605.25376)</a:t>
-            </a:r>
-          </a:p>
-          <a:p>
-            <a:pPr>
-              <a:spcAft>
-                <a:spcPts val="1000"/>
-              </a:spcAft>
-              <a:defRPr sz="1800">
-                <a:solidFill>
-                  <a:srgbClr val="C3CDDC"/>
-                </a:solidFill>
-                <a:latin typeface="Aptos"/>
-              </a:defRPr>
-            </a:pPr>
-            <a:r>
-              <a:t>Auditing, Monitoring, and Intervention (arXiv:2605.16198)</a:t>
+              <a:t>Agent Skills for Large Language Models (arXiv:2602.12430)</a:t>
             </a:r>
           </a:p>
         </p:txBody>
@@ -10589,7 +11104,7 @@
               </a:defRPr>
             </a:pPr>
             <a:r>
-              <a:t>June 7, 2026 scout addendum: six newly surfaced papers</a:t>
+              <a:t>June 14, 2026 scout addendum: eight newly surfaced papers, frameworks, and products</a:t>
             </a:r>
           </a:p>
         </p:txBody>
@@ -10673,7 +11188,7 @@
               </a:defRPr>
             </a:pPr>
             <a:r>
-              <a:t>The latest scout update adds six papers that materially improve the stack, especially around skill composition, verifiable skill representations, and…</a:t>
+              <a:t>The June 14 scout adds eight items across all three search targets — new benchmarks, skill governance frameworks, OWASP/MITRE/NIST guidelines, and se…</a:t>
             </a:r>
           </a:p>
           <a:p>
@@ -10689,7 +11204,7 @@
               </a:defRPr>
             </a:pPr>
             <a:r>
-              <a:t>SkillSafetyBench (arXiv:2605.12015)</a:t>
+              <a:t>EmbodiedGovBench (arXiv:2604.11174)</a:t>
             </a:r>
           </a:p>
           <a:p>
@@ -10705,7 +11220,7 @@
               </a:defRPr>
             </a:pPr>
             <a:r>
-              <a:t>First benchmark specifically targeting skill-level attack surfaces</a:t>
+              <a:t>First benchmark specifically targeting governance-oriented evaluation of embodied agent systems (not just task success)</a:t>
             </a:r>
           </a:p>
           <a:p>
@@ -10721,7 +11236,7 @@
               </a:defRPr>
             </a:pPr>
             <a:r>
-              <a:t>Most relevant to Layer 0 + Layer 2</a:t>
+              <a:t>Covers seven governance dimensions: unauthorized capability invocation, runtime drift robustness, recovery success, policy portability, version upgra…</a:t>
             </a:r>
           </a:p>
           <a:p>
@@ -10737,7 +11252,7 @@
               </a:defRPr>
             </a:pPr>
             <a:r>
-              <a:t>Why it matters: governance at the skill layer needs a benchmark, not just threat claims</a:t>
+              <a:t>Most relevant to Layer 2</a:t>
             </a:r>
           </a:p>
         </p:txBody>
@@ -10853,7 +11368,7 @@
             <a:avLst/>
           </a:prstGeom>
           <a:solidFill>
-            <a:srgbClr val="3ECFB9"/>
+            <a:srgbClr val="3F8EFC"/>
           </a:solidFill>
           <a:ln>
             <a:noFill/>
@@ -10889,8 +11404,8 @@
         </p:nvSpPr>
         <p:spPr>
           <a:xfrm>
-            <a:off x="731520" y="2011680"/>
-            <a:ext cx="9601200" cy="914400"/>
+            <a:off x="548640" y="384048"/>
+            <a:ext cx="10607040" cy="548640"/>
           </a:xfrm>
           <a:prstGeom prst="rect">
             <a:avLst/>
@@ -10904,7 +11419,7 @@
           <a:lstStyle/>
           <a:p>
             <a:pPr algn="l">
-              <a:defRPr sz="3000" b="1">
+              <a:defRPr sz="2200" b="1">
                 <a:solidFill>
                   <a:srgbClr val="F5F7FA"/>
                 </a:solidFill>
@@ -10912,66 +11427,32 @@
               </a:defRPr>
             </a:pPr>
             <a:r>
-              <a:t>Papers &amp; Products</a:t>
-            </a:r>
-          </a:p>
-        </p:txBody>
-      </p:sp>
-      <p:sp>
-        <p:nvSpPr>
-          <p:cNvPr id="5" name="TextBox 4"/>
-          <p:cNvSpPr txBox="1"/>
-          <p:nvPr/>
-        </p:nvSpPr>
-        <p:spPr>
-          <a:xfrm>
-            <a:off x="749808" y="3063240"/>
-            <a:ext cx="7772400" cy="548640"/>
-          </a:xfrm>
-          <a:prstGeom prst="rect">
-            <a:avLst/>
-          </a:prstGeom>
-          <a:noFill/>
-        </p:spPr>
-        <p:txBody>
-          <a:bodyPr wrap="square">
-            <a:spAutoFit/>
-          </a:bodyPr>
-          <a:lstStyle/>
-          <a:p>
-            <a:pPr algn="l">
-              <a:defRPr sz="1300" b="0">
-                <a:solidFill>
-                  <a:srgbClr val="C3CDDC"/>
-                </a:solidFill>
-                <a:latin typeface="Aptos"/>
-              </a:defRPr>
-            </a:pPr>
-            <a:r>
-              <a:t>Curated from the current markdown report</a:t>
-            </a:r>
-          </a:p>
-        </p:txBody>
-      </p:sp>
-      <p:sp>
-        <p:nvSpPr>
-          <p:cNvPr id="6" name="Hexagon 5"/>
+              <a:t>June 12, 2026 scout addendum: two newly surfaced papers</a:t>
+            </a:r>
+          </a:p>
+        </p:txBody>
+      </p:sp>
+      <p:sp>
+        <p:nvSpPr>
+          <p:cNvPr id="5" name="Rounded Rectangle 4"/>
           <p:cNvSpPr/>
           <p:nvPr/>
         </p:nvSpPr>
         <p:spPr>
           <a:xfrm>
-            <a:off x="9509760" y="1645920"/>
-            <a:ext cx="1645920" cy="1645920"/>
-          </a:xfrm>
-          <a:prstGeom prst="hexagon">
+            <a:off x="502920" y="1143000"/>
+            <a:ext cx="11155680" cy="5303520"/>
+          </a:xfrm>
+          <a:prstGeom prst="roundRect">
             <a:avLst/>
           </a:prstGeom>
           <a:solidFill>
-            <a:srgbClr val="3ECFB9"/>
+            <a:srgbClr val="18243A"/>
           </a:solidFill>
           <a:ln>
-            <a:noFill/>
+            <a:solidFill>
+              <a:srgbClr val="18243A"/>
+            </a:solidFill>
           </a:ln>
         </p:spPr>
         <p:style>
@@ -10998,6 +11479,109 @@
       </p:sp>
       <p:sp>
         <p:nvSpPr>
+          <p:cNvPr id="6" name="TextBox 5"/>
+          <p:cNvSpPr txBox="1"/>
+          <p:nvPr/>
+        </p:nvSpPr>
+        <p:spPr>
+          <a:xfrm>
+            <a:off x="777240" y="1463040"/>
+            <a:ext cx="10424160" cy="4572000"/>
+          </a:xfrm>
+          <a:prstGeom prst="rect">
+            <a:avLst/>
+          </a:prstGeom>
+          <a:noFill/>
+        </p:spPr>
+        <p:txBody>
+          <a:bodyPr wrap="square">
+            <a:spAutoFit/>
+          </a:bodyPr>
+          <a:lstStyle/>
+          <a:p>
+            <a:pPr>
+              <a:spcAft>
+                <a:spcPts val="1000"/>
+              </a:spcAft>
+              <a:defRPr sz="1600">
+                <a:solidFill>
+                  <a:srgbClr val="C3CDDC"/>
+                </a:solidFill>
+                <a:latin typeface="Aptos"/>
+              </a:defRPr>
+            </a:pPr>
+            <a:r>
+              <a:t>The June 12 scout adds two papers that expand the stack in different directions — one on learning-based sequential validation (static-time) and one o…</a:t>
+            </a:r>
+          </a:p>
+          <a:p>
+            <a:pPr>
+              <a:spcAft>
+                <a:spcPts val="1000"/>
+              </a:spcAft>
+              <a:defRPr sz="1600">
+                <a:solidFill>
+                  <a:srgbClr val="C3CDDC"/>
+                </a:solidFill>
+                <a:latin typeface="Aptos"/>
+              </a:defRPr>
+            </a:pPr>
+            <a:r>
+              <a:t>Learning Correct Behavior from Examples (arXiv:2605.03159)</a:t>
+            </a:r>
+          </a:p>
+          <a:p>
+            <a:pPr>
+              <a:spcAft>
+                <a:spcPts val="1000"/>
+              </a:spcAft>
+              <a:defRPr sz="1600">
+                <a:solidFill>
+                  <a:srgbClr val="C3CDDC"/>
+                </a:solidFill>
+                <a:latin typeface="Aptos"/>
+              </a:defRPr>
+            </a:pPr>
+            <a:r>
+              <a:t>Learns correct sequential behavior from 2-10 passing execution traces and validates new executions against a learned model</a:t>
+            </a:r>
+          </a:p>
+          <a:p>
+            <a:pPr>
+              <a:spcAft>
+                <a:spcPts val="1000"/>
+              </a:spcAft>
+              <a:defRPr sz="1600">
+                <a:solidFill>
+                  <a:srgbClr val="C3CDDC"/>
+                </a:solidFill>
+                <a:latin typeface="Aptos"/>
+              </a:defRPr>
+            </a:pPr>
+            <a:r>
+              <a:t>Most relevant to Layer 0 + Layer 1</a:t>
+            </a:r>
+          </a:p>
+          <a:p>
+            <a:pPr>
+              <a:spcAft>
+                <a:spcPts val="1000"/>
+              </a:spcAft>
+              <a:defRPr sz="1600">
+                <a:solidFill>
+                  <a:srgbClr val="C3CDDC"/>
+                </a:solidFill>
+                <a:latin typeface="Aptos"/>
+              </a:defRPr>
+            </a:pPr>
+            <a:r>
+              <a:t>Why it matters: static governance usually requires either exhaustive specifications or runtime monitors; this shows a middle path — learning ground t…</a:t>
+            </a:r>
+          </a:p>
+        </p:txBody>
+      </p:sp>
+      <p:sp>
+        <p:nvSpPr>
           <p:cNvPr id="7" name="TextBox 6"/>
           <p:cNvSpPr txBox="1"/>
           <p:nvPr/>
@@ -11021,12 +11605,12 @@
             <a:pPr algn="r">
               <a:defRPr sz="900">
                 <a:solidFill>
-                  <a:srgbClr val="3ECFB9"/>
-                </a:solidFill>
-              </a:defRPr>
-            </a:pPr>
-            <a:r>
-              <a:t>Section</a:t>
+                  <a:srgbClr val="3F8EFC"/>
+                </a:solidFill>
+              </a:defRPr>
+            </a:pPr>
+            <a:r>
+              <a:t>EvaPaper</a:t>
             </a:r>
           </a:p>
         </p:txBody>
@@ -11107,7 +11691,7 @@
             <a:avLst/>
           </a:prstGeom>
           <a:solidFill>
-            <a:srgbClr val="3ECFB9"/>
+            <a:srgbClr val="3F8EFC"/>
           </a:solidFill>
           <a:ln>
             <a:noFill/>
@@ -11166,7 +11750,7 @@
               </a:defRPr>
             </a:pPr>
             <a:r>
-              <a:t>1. BeSafe-Bench (BSB)</a:t>
+              <a:t>June 7, 2026 scout addendum: six newly surfaced papers</a:t>
             </a:r>
           </a:p>
         </p:txBody>
@@ -11250,7 +11834,7 @@
               </a:defRPr>
             </a:pPr>
             <a:r>
-              <a:t>arXiv ID: 2603.25747</a:t>
+              <a:t>The latest scout update adds six papers that materially improve the stack, especially around skill composition, verifiable skill representations, and…</a:t>
             </a:r>
           </a:p>
           <a:p>
@@ -11266,7 +11850,7 @@
               </a:defRPr>
             </a:pPr>
             <a:r>
-              <a:t>URL: https://arxiv.org/abs/2603.25747</a:t>
+              <a:t>SkillSafetyBench (arXiv:2605.12015)</a:t>
             </a:r>
           </a:p>
           <a:p>
@@ -11282,7 +11866,7 @@
               </a:defRPr>
             </a:pPr>
             <a:r>
-              <a:t>PDF: https://arxiv.org/pdf/2603.25747</a:t>
+              <a:t>First benchmark specifically targeting skill-level attack surfaces</a:t>
             </a:r>
           </a:p>
           <a:p>
@@ -11298,7 +11882,7 @@
               </a:defRPr>
             </a:pPr>
             <a:r>
-              <a:t>Authors: Xuetao Wei et al.</a:t>
+              <a:t>Most relevant to Layer 0 + Layer 2</a:t>
             </a:r>
           </a:p>
           <a:p>
@@ -11314,7 +11898,7 @@
               </a:defRPr>
             </a:pPr>
             <a:r>
-              <a:t>Date: January 2026</a:t>
+              <a:t>Why it matters: governance at the skill layer needs a benchmark, not just threat claims</a:t>
             </a:r>
           </a:p>
         </p:txBody>
@@ -11344,7 +11928,7 @@
             <a:pPr algn="r">
               <a:defRPr sz="900">
                 <a:solidFill>
-                  <a:srgbClr val="3ECFB9"/>
+                  <a:srgbClr val="3F8EFC"/>
                 </a:solidFill>
               </a:defRPr>
             </a:pPr>

</xml_diff>